<commit_message>
Update to the code that generates the regional maps to show the legend horizontally and below the map of the island
</commit_message>
<xml_diff>
--- a/project_reports/Poster_RiveraruizJose-1-36x48-1.pptx
+++ b/project_reports/Poster_RiveraruizJose-1-36x48-1.pptx
@@ -5,12 +5,11 @@
     <p:sldMasterId id="2147483648" r:id="rId4"/>
   </p:sldMasterIdLst>
   <p:notesMasterIdLst>
-    <p:notesMasterId r:id="rId8"/>
+    <p:notesMasterId r:id="rId7"/>
   </p:notesMasterIdLst>
   <p:sldIdLst>
     <p:sldId id="258" r:id="rId5"/>
-    <p:sldId id="256" r:id="rId6"/>
-    <p:sldId id="257" r:id="rId7"/>
+    <p:sldId id="257" r:id="rId6"/>
   </p:sldIdLst>
   <p:sldSz cx="43891200" cy="32918400"/>
   <p:notesSz cx="6858000" cy="9144000"/>
@@ -211,7 +210,7 @@
             <a:fld id="{CFB1F554-8471-F74E-95A3-3E7FC8AE6388}" type="datetimeFigureOut">
               <a:rPr lang="en-US" smtClean="0"/>
               <a:pPr/>
-              <a:t>4/24/26</a:t>
+              <a:t>4/29/26</a:t>
             </a:fld>
             <a:endParaRPr lang="en-US"/>
           </a:p>
@@ -592,88 +591,6 @@
 </p:notes>
 </file>
 
-<file path=ppt/notesSlides/notesSlide2.xml><?xml version="1.0" encoding="utf-8"?>
-<p:notes xmlns:a="http://schemas.openxmlformats.org/drawingml/2006/main" xmlns:r="http://schemas.openxmlformats.org/officeDocument/2006/relationships" xmlns:p="http://schemas.openxmlformats.org/presentationml/2006/main">
-  <p:cSld>
-    <p:spTree>
-      <p:nvGrpSpPr>
-        <p:cNvPr id="1" name=""/>
-        <p:cNvGrpSpPr/>
-        <p:nvPr/>
-      </p:nvGrpSpPr>
-      <p:grpSpPr>
-        <a:xfrm>
-          <a:off x="0" y="0"/>
-          <a:ext cx="0" cy="0"/>
-          <a:chOff x="0" y="0"/>
-          <a:chExt cx="0" cy="0"/>
-        </a:xfrm>
-      </p:grpSpPr>
-      <p:sp>
-        <p:nvSpPr>
-          <p:cNvPr id="2" name="Slide Image Placeholder 1"/>
-          <p:cNvSpPr>
-            <a:spLocks noGrp="1" noRot="1" noChangeAspect="1"/>
-          </p:cNvSpPr>
-          <p:nvPr>
-            <p:ph type="sldImg"/>
-          </p:nvPr>
-        </p:nvSpPr>
-        <p:spPr/>
-      </p:sp>
-      <p:sp>
-        <p:nvSpPr>
-          <p:cNvPr id="3" name="Notes Placeholder 2"/>
-          <p:cNvSpPr>
-            <a:spLocks noGrp="1"/>
-          </p:cNvSpPr>
-          <p:nvPr>
-            <p:ph type="body" idx="1"/>
-          </p:nvPr>
-        </p:nvSpPr>
-        <p:spPr/>
-        <p:txBody>
-          <a:bodyPr>
-            <a:normAutofit/>
-          </a:bodyPr>
-          <a:lstStyle/>
-          <a:p>
-            <a:endParaRPr lang="en-US" dirty="0"/>
-          </a:p>
-        </p:txBody>
-      </p:sp>
-      <p:sp>
-        <p:nvSpPr>
-          <p:cNvPr id="4" name="Slide Number Placeholder 3"/>
-          <p:cNvSpPr>
-            <a:spLocks noGrp="1"/>
-          </p:cNvSpPr>
-          <p:nvPr>
-            <p:ph type="sldNum" sz="quarter" idx="10"/>
-          </p:nvPr>
-        </p:nvSpPr>
-        <p:spPr/>
-        <p:txBody>
-          <a:bodyPr/>
-          <a:lstStyle/>
-          <a:p>
-            <a:fld id="{EC5E2536-F949-A046-9408-77F5280C62D9}" type="slidenum">
-              <a:rPr lang="en-US" smtClean="0"/>
-              <a:pPr/>
-              <a:t>2</a:t>
-            </a:fld>
-            <a:endParaRPr lang="en-US"/>
-          </a:p>
-        </p:txBody>
-      </p:sp>
-    </p:spTree>
-  </p:cSld>
-  <p:clrMapOvr>
-    <a:masterClrMapping/>
-  </p:clrMapOvr>
-</p:notes>
-</file>
-
 <file path=ppt/slideLayouts/slideLayout1.xml><?xml version="1.0" encoding="utf-8"?>
 <p:sldLayout xmlns:a="http://schemas.openxmlformats.org/drawingml/2006/main" xmlns:r="http://schemas.openxmlformats.org/officeDocument/2006/relationships" xmlns:p="http://schemas.openxmlformats.org/presentationml/2006/main" type="title" preserve="1">
   <p:cSld name="Title Slide">
@@ -854,7 +771,7 @@
             <a:fld id="{0C2C9624-8537-344B-A181-774C3CF89A66}" type="datetimeFigureOut">
               <a:rPr lang="en-US" smtClean="0"/>
               <a:pPr/>
-              <a:t>4/24/26</a:t>
+              <a:t>4/29/26</a:t>
             </a:fld>
             <a:endParaRPr lang="en-US"/>
           </a:p>
@@ -1019,7 +936,7 @@
             <a:fld id="{0C2C9624-8537-344B-A181-774C3CF89A66}" type="datetimeFigureOut">
               <a:rPr lang="en-US" smtClean="0"/>
               <a:pPr/>
-              <a:t>4/24/26</a:t>
+              <a:t>4/29/26</a:t>
             </a:fld>
             <a:endParaRPr lang="en-US"/>
           </a:p>
@@ -1194,7 +1111,7 @@
             <a:fld id="{0C2C9624-8537-344B-A181-774C3CF89A66}" type="datetimeFigureOut">
               <a:rPr lang="en-US" smtClean="0"/>
               <a:pPr/>
-              <a:t>4/24/26</a:t>
+              <a:t>4/29/26</a:t>
             </a:fld>
             <a:endParaRPr lang="en-US"/>
           </a:p>
@@ -1359,7 +1276,7 @@
             <a:fld id="{0C2C9624-8537-344B-A181-774C3CF89A66}" type="datetimeFigureOut">
               <a:rPr lang="en-US" smtClean="0"/>
               <a:pPr/>
-              <a:t>4/24/26</a:t>
+              <a:t>4/29/26</a:t>
             </a:fld>
             <a:endParaRPr lang="en-US"/>
           </a:p>
@@ -1601,7 +1518,7 @@
             <a:fld id="{0C2C9624-8537-344B-A181-774C3CF89A66}" type="datetimeFigureOut">
               <a:rPr lang="en-US" smtClean="0"/>
               <a:pPr/>
-              <a:t>4/24/26</a:t>
+              <a:t>4/29/26</a:t>
             </a:fld>
             <a:endParaRPr lang="en-US"/>
           </a:p>
@@ -1883,7 +1800,7 @@
             <a:fld id="{0C2C9624-8537-344B-A181-774C3CF89A66}" type="datetimeFigureOut">
               <a:rPr lang="en-US" smtClean="0"/>
               <a:pPr/>
-              <a:t>4/24/26</a:t>
+              <a:t>4/29/26</a:t>
             </a:fld>
             <a:endParaRPr lang="en-US"/>
           </a:p>
@@ -2304,7 +2221,7 @@
             <a:fld id="{0C2C9624-8537-344B-A181-774C3CF89A66}" type="datetimeFigureOut">
               <a:rPr lang="en-US" smtClean="0"/>
               <a:pPr/>
-              <a:t>4/24/26</a:t>
+              <a:t>4/29/26</a:t>
             </a:fld>
             <a:endParaRPr lang="en-US"/>
           </a:p>
@@ -2418,7 +2335,7 @@
             <a:fld id="{0C2C9624-8537-344B-A181-774C3CF89A66}" type="datetimeFigureOut">
               <a:rPr lang="en-US" smtClean="0"/>
               <a:pPr/>
-              <a:t>4/24/26</a:t>
+              <a:t>4/29/26</a:t>
             </a:fld>
             <a:endParaRPr lang="en-US"/>
           </a:p>
@@ -2510,7 +2427,7 @@
             <a:fld id="{0C2C9624-8537-344B-A181-774C3CF89A66}" type="datetimeFigureOut">
               <a:rPr lang="en-US" smtClean="0"/>
               <a:pPr/>
-              <a:t>4/24/26</a:t>
+              <a:t>4/29/26</a:t>
             </a:fld>
             <a:endParaRPr lang="en-US"/>
           </a:p>
@@ -2782,7 +2699,7 @@
             <a:fld id="{0C2C9624-8537-344B-A181-774C3CF89A66}" type="datetimeFigureOut">
               <a:rPr lang="en-US" smtClean="0"/>
               <a:pPr/>
-              <a:t>4/24/26</a:t>
+              <a:t>4/29/26</a:t>
             </a:fld>
             <a:endParaRPr lang="en-US"/>
           </a:p>
@@ -3031,7 +2948,7 @@
             <a:fld id="{0C2C9624-8537-344B-A181-774C3CF89A66}" type="datetimeFigureOut">
               <a:rPr lang="en-US" smtClean="0"/>
               <a:pPr/>
-              <a:t>4/24/26</a:t>
+              <a:t>4/29/26</a:t>
             </a:fld>
             <a:endParaRPr lang="en-US"/>
           </a:p>
@@ -3239,7 +3156,7 @@
             <a:fld id="{0C2C9624-8537-344B-A181-774C3CF89A66}" type="datetimeFigureOut">
               <a:rPr lang="en-US" smtClean="0"/>
               <a:pPr/>
-              <a:t>4/24/26</a:t>
+              <a:t>4/29/26</a:t>
             </a:fld>
             <a:endParaRPr lang="en-US"/>
           </a:p>
@@ -6323,51 +6240,6 @@
       </p:pic>
       <p:pic>
         <p:nvPicPr>
-          <p:cNvPr id="11" name="Picture 10">
-            <a:extLst>
-              <a:ext uri="{FF2B5EF4-FFF2-40B4-BE49-F238E27FC236}">
-                <a16:creationId xmlns:a16="http://schemas.microsoft.com/office/drawing/2014/main" id="{BF35DDAC-38FE-A3B8-0A07-AF646DF2F4D9}"/>
-              </a:ext>
-            </a:extLst>
-          </p:cNvPr>
-          <p:cNvPicPr>
-            <a:picLocks noChangeAspect="1"/>
-          </p:cNvPicPr>
-          <p:nvPr/>
-        </p:nvPicPr>
-        <p:blipFill>
-          <a:blip r:embed="rId5">
-            <a:alphaModFix amt="85000"/>
-            <a:extLst>
-              <a:ext uri="{28A0092B-C50C-407E-A947-70E740481C1C}">
-                <a14:useLocalDpi xmlns:a14="http://schemas.microsoft.com/office/drawing/2010/main" val="0"/>
-              </a:ext>
-            </a:extLst>
-          </a:blip>
-          <a:stretch>
-            <a:fillRect/>
-          </a:stretch>
-        </p:blipFill>
-        <p:spPr>
-          <a:xfrm>
-            <a:off x="3972812" y="28301247"/>
-            <a:ext cx="7527701" cy="3583640"/>
-          </a:xfrm>
-          <a:prstGeom prst="rect">
-            <a:avLst/>
-          </a:prstGeom>
-          <a:ln>
-            <a:solidFill>
-              <a:schemeClr val="tx1"/>
-            </a:solidFill>
-          </a:ln>
-          <a:effectLst>
-            <a:softEdge rad="127000"/>
-          </a:effectLst>
-        </p:spPr>
-      </p:pic>
-      <p:pic>
-        <p:nvPicPr>
           <p:cNvPr id="12" name="Picture 11" descr="A graph with lines and numbers&#10;&#10;AI-generated content may be incorrect.">
             <a:extLst>
               <a:ext uri="{FF2B5EF4-FFF2-40B4-BE49-F238E27FC236}">
@@ -6381,7 +6253,7 @@
           <p:nvPr/>
         </p:nvPicPr>
         <p:blipFill>
-          <a:blip r:embed="rId6">
+          <a:blip r:embed="rId5">
             <a:alphaModFix amt="85000"/>
             <a:extLst>
               <a:ext uri="{28A0092B-C50C-407E-A947-70E740481C1C}">
@@ -6418,7 +6290,7 @@
           <p:nvPr/>
         </p:nvPicPr>
         <p:blipFill>
-          <a:blip r:embed="rId7">
+          <a:blip r:embed="rId6">
             <a:alphaModFix amt="85000"/>
           </a:blip>
           <a:stretch>
@@ -6450,7 +6322,7 @@
           <p:nvPr/>
         </p:nvPicPr>
         <p:blipFill>
-          <a:blip r:embed="rId8">
+          <a:blip r:embed="rId7">
             <a:alphaModFix amt="85000"/>
           </a:blip>
           <a:stretch>
@@ -6467,6 +6339,72 @@
           </a:prstGeom>
         </p:spPr>
       </p:pic>
+      <p:pic>
+        <p:nvPicPr>
+          <p:cNvPr id="13" name="Picture 12" descr="A map of different colored areas&#10;&#10;AI-generated content may be incorrect.">
+            <a:extLst>
+              <a:ext uri="{FF2B5EF4-FFF2-40B4-BE49-F238E27FC236}">
+                <a16:creationId xmlns:a16="http://schemas.microsoft.com/office/drawing/2014/main" id="{2A6A3490-1966-B4EA-6FE6-A7C5F29F22D5}"/>
+              </a:ext>
+            </a:extLst>
+          </p:cNvPr>
+          <p:cNvPicPr>
+            <a:picLocks noChangeAspect="1"/>
+          </p:cNvPicPr>
+          <p:nvPr/>
+        </p:nvPicPr>
+        <p:blipFill>
+          <a:blip r:embed="rId8"/>
+          <a:stretch>
+            <a:fillRect/>
+          </a:stretch>
+        </p:blipFill>
+        <p:spPr>
+          <a:xfrm>
+            <a:off x="8329698" y="29256382"/>
+            <a:ext cx="6040247" cy="2310284"/>
+          </a:xfrm>
+          <a:prstGeom prst="rect">
+            <a:avLst/>
+          </a:prstGeom>
+          <a:ln>
+            <a:noFill/>
+          </a:ln>
+        </p:spPr>
+      </p:pic>
+      <p:pic>
+        <p:nvPicPr>
+          <p:cNvPr id="28" name="Picture 27" descr="A map of different colored areas&#10;&#10;AI-generated content may be incorrect.">
+            <a:extLst>
+              <a:ext uri="{FF2B5EF4-FFF2-40B4-BE49-F238E27FC236}">
+                <a16:creationId xmlns:a16="http://schemas.microsoft.com/office/drawing/2014/main" id="{0CE0FB28-63F6-F12B-A5C5-4A34C958E91D}"/>
+              </a:ext>
+            </a:extLst>
+          </p:cNvPr>
+          <p:cNvPicPr>
+            <a:picLocks noChangeAspect="1"/>
+          </p:cNvPicPr>
+          <p:nvPr/>
+        </p:nvPicPr>
+        <p:blipFill>
+          <a:blip r:embed="rId9"/>
+          <a:stretch>
+            <a:fillRect/>
+          </a:stretch>
+        </p:blipFill>
+        <p:spPr>
+          <a:xfrm>
+            <a:off x="1435798" y="29256382"/>
+            <a:ext cx="6031429" cy="2310284"/>
+          </a:xfrm>
+          <a:prstGeom prst="rect">
+            <a:avLst/>
+          </a:prstGeom>
+          <a:ln>
+            <a:noFill/>
+          </a:ln>
+        </p:spPr>
+      </p:pic>
     </p:spTree>
     <p:extLst>
       <p:ext uri="{BB962C8B-B14F-4D97-AF65-F5344CB8AC3E}">
@@ -6481,1623 +6419,6 @@
 </file>
 
 <file path=ppt/slides/slide2.xml><?xml version="1.0" encoding="utf-8"?>
-<p:sld xmlns:a="http://schemas.openxmlformats.org/drawingml/2006/main" xmlns:r="http://schemas.openxmlformats.org/officeDocument/2006/relationships" xmlns:p="http://schemas.openxmlformats.org/presentationml/2006/main">
-  <p:cSld>
-    <p:bg>
-      <p:bgPr>
-        <a:solidFill>
-          <a:schemeClr val="bg1">
-            <a:lumMod val="95000"/>
-          </a:schemeClr>
-        </a:solidFill>
-        <a:effectLst/>
-      </p:bgPr>
-    </p:bg>
-    <p:spTree>
-      <p:nvGrpSpPr>
-        <p:cNvPr id="1" name=""/>
-        <p:cNvGrpSpPr/>
-        <p:nvPr/>
-      </p:nvGrpSpPr>
-      <p:grpSpPr>
-        <a:xfrm>
-          <a:off x="0" y="0"/>
-          <a:ext cx="0" cy="0"/>
-          <a:chOff x="0" y="0"/>
-          <a:chExt cx="0" cy="0"/>
-        </a:xfrm>
-      </p:grpSpPr>
-      <p:sp>
-        <p:nvSpPr>
-          <p:cNvPr id="264" name="TextBox 263"/>
-          <p:cNvSpPr txBox="1"/>
-          <p:nvPr/>
-        </p:nvSpPr>
-        <p:spPr>
-          <a:xfrm>
-            <a:off x="14733087" y="952545"/>
-            <a:ext cx="27965364" cy="3954929"/>
-          </a:xfrm>
-          <a:prstGeom prst="rect">
-            <a:avLst/>
-          </a:prstGeom>
-          <a:solidFill>
-            <a:srgbClr val="CC0033"/>
-          </a:solidFill>
-          <a:ln>
-            <a:noFill/>
-          </a:ln>
-          <a:effectLst/>
-        </p:spPr>
-        <p:txBody>
-          <a:bodyPr wrap="square" rtlCol="0" anchor="ctr">
-            <a:spAutoFit/>
-          </a:bodyPr>
-          <a:lstStyle/>
-          <a:p>
-            <a:pPr algn="ctr"/>
-            <a:r>
-              <a:rPr lang="en-US" sz="9900" b="1" dirty="0">
-                <a:solidFill>
-                  <a:schemeClr val="bg1"/>
-                </a:solidFill>
-              </a:rPr>
-              <a:t>Title</a:t>
-            </a:r>
-          </a:p>
-          <a:p>
-            <a:pPr algn="ctr"/>
-            <a:r>
-              <a:rPr lang="en-US" sz="5400" dirty="0">
-                <a:solidFill>
-                  <a:schemeClr val="bg1"/>
-                </a:solidFill>
-                <a:latin typeface="Arial"/>
-                <a:cs typeface="Arial"/>
-              </a:rPr>
-              <a:t>Names </a:t>
-            </a:r>
-            <a:endParaRPr lang="en-US" sz="5400" baseline="30000" dirty="0">
-              <a:solidFill>
-                <a:schemeClr val="bg1"/>
-              </a:solidFill>
-              <a:latin typeface="Arial"/>
-              <a:cs typeface="Arial"/>
-            </a:endParaRPr>
-          </a:p>
-          <a:p>
-            <a:pPr algn="ctr"/>
-            <a:r>
-              <a:rPr lang="en-US" sz="5400" dirty="0">
-                <a:solidFill>
-                  <a:schemeClr val="bg1"/>
-                </a:solidFill>
-                <a:latin typeface="Arial"/>
-                <a:cs typeface="Arial"/>
-              </a:rPr>
-              <a:t>Institute</a:t>
-            </a:r>
-          </a:p>
-          <a:p>
-            <a:pPr algn="ctr"/>
-            <a:endParaRPr lang="en-US" sz="2000" dirty="0">
-              <a:solidFill>
-                <a:schemeClr val="bg1"/>
-              </a:solidFill>
-              <a:latin typeface="Arial"/>
-              <a:cs typeface="Arial"/>
-            </a:endParaRPr>
-          </a:p>
-          <a:p>
-            <a:pPr algn="ctr"/>
-            <a:endParaRPr lang="en-US" sz="1200" dirty="0">
-              <a:solidFill>
-                <a:schemeClr val="bg1"/>
-              </a:solidFill>
-              <a:latin typeface="Arial"/>
-              <a:cs typeface="Arial"/>
-            </a:endParaRPr>
-          </a:p>
-          <a:p>
-            <a:pPr algn="ctr"/>
-            <a:endParaRPr lang="en-US" sz="1200" dirty="0">
-              <a:solidFill>
-                <a:schemeClr val="bg1"/>
-              </a:solidFill>
-              <a:latin typeface="Arial"/>
-              <a:cs typeface="Arial"/>
-            </a:endParaRPr>
-          </a:p>
-        </p:txBody>
-      </p:sp>
-      <p:pic>
-        <p:nvPicPr>
-          <p:cNvPr id="4" name="Picture 9">
-            <a:extLst>
-              <a:ext uri="{FF2B5EF4-FFF2-40B4-BE49-F238E27FC236}">
-                <a16:creationId xmlns:a16="http://schemas.microsoft.com/office/drawing/2014/main" id="{A6731E36-9848-25F2-56CF-26D2FB25FBB7}"/>
-              </a:ext>
-            </a:extLst>
-          </p:cNvPr>
-          <p:cNvPicPr>
-            <a:picLocks noChangeAspect="1" noChangeArrowheads="1"/>
-          </p:cNvPicPr>
-          <p:nvPr/>
-        </p:nvPicPr>
-        <p:blipFill>
-          <a:blip r:embed="rId3"/>
-          <a:srcRect/>
-          <a:stretch/>
-        </p:blipFill>
-        <p:spPr bwMode="auto">
-          <a:xfrm>
-            <a:off x="4118609" y="1962291"/>
-            <a:ext cx="7634153" cy="2263089"/>
-          </a:xfrm>
-          <a:prstGeom prst="rect">
-            <a:avLst/>
-          </a:prstGeom>
-          <a:noFill/>
-          <a:extLst>
-            <a:ext uri="{909E8E84-426E-40DD-AFC4-6F175D3DCCD1}">
-              <a14:hiddenFill xmlns:a14="http://schemas.microsoft.com/office/drawing/2010/main">
-                <a:solidFill>
-                  <a:srgbClr val="FFFFFF"/>
-                </a:solidFill>
-              </a14:hiddenFill>
-            </a:ext>
-          </a:extLst>
-        </p:spPr>
-      </p:pic>
-      <p:sp>
-        <p:nvSpPr>
-          <p:cNvPr id="15" name="Rectangle 31">
-            <a:extLst>
-              <a:ext uri="{FF2B5EF4-FFF2-40B4-BE49-F238E27FC236}">
-                <a16:creationId xmlns:a16="http://schemas.microsoft.com/office/drawing/2014/main" id="{BFFDC9AF-D579-FC3D-231D-A14B10EEA73A}"/>
-              </a:ext>
-            </a:extLst>
-          </p:cNvPr>
-          <p:cNvSpPr>
-            <a:spLocks noChangeArrowheads="1"/>
-          </p:cNvSpPr>
-          <p:nvPr/>
-        </p:nvSpPr>
-        <p:spPr bwMode="auto">
-          <a:xfrm>
-            <a:off x="15227630" y="5486833"/>
-            <a:ext cx="13461027" cy="6738635"/>
-          </a:xfrm>
-          <a:prstGeom prst="rect">
-            <a:avLst/>
-          </a:prstGeom>
-          <a:solidFill>
-            <a:srgbClr val="E5E5E5"/>
-          </a:solidFill>
-          <a:ln w="12700" cmpd="sng">
-            <a:solidFill>
-              <a:schemeClr val="tx1">
-                <a:lumMod val="75000"/>
-                <a:lumOff val="25000"/>
-              </a:schemeClr>
-            </a:solidFill>
-            <a:miter lim="800000"/>
-            <a:headEnd/>
-            <a:tailEnd/>
-          </a:ln>
-        </p:spPr>
-        <p:txBody>
-          <a:bodyPr wrap="square" anchor="t"/>
-          <a:lstStyle/>
-          <a:p>
-            <a:endParaRPr lang="en-US" sz="4000" baseline="0" dirty="0"/>
-          </a:p>
-        </p:txBody>
-      </p:sp>
-      <p:sp>
-        <p:nvSpPr>
-          <p:cNvPr id="16" name="Rectangle 69">
-            <a:extLst>
-              <a:ext uri="{FF2B5EF4-FFF2-40B4-BE49-F238E27FC236}">
-                <a16:creationId xmlns:a16="http://schemas.microsoft.com/office/drawing/2014/main" id="{4E714858-50BC-DDA2-F04D-C22057F9BB33}"/>
-              </a:ext>
-            </a:extLst>
-          </p:cNvPr>
-          <p:cNvSpPr/>
-          <p:nvPr/>
-        </p:nvSpPr>
-        <p:spPr>
-          <a:xfrm>
-            <a:off x="15227630" y="5486833"/>
-            <a:ext cx="13461027" cy="1368125"/>
-          </a:xfrm>
-          <a:custGeom>
-            <a:avLst/>
-            <a:gdLst>
-              <a:gd name="connsiteX0" fmla="*/ 0 w 16106775"/>
-              <a:gd name="connsiteY0" fmla="*/ 0 h 646331"/>
-              <a:gd name="connsiteX1" fmla="*/ 16106775 w 16106775"/>
-              <a:gd name="connsiteY1" fmla="*/ 0 h 646331"/>
-              <a:gd name="connsiteX2" fmla="*/ 16106775 w 16106775"/>
-              <a:gd name="connsiteY2" fmla="*/ 646331 h 646331"/>
-              <a:gd name="connsiteX3" fmla="*/ 0 w 16106775"/>
-              <a:gd name="connsiteY3" fmla="*/ 646331 h 646331"/>
-              <a:gd name="connsiteX4" fmla="*/ 0 w 16106775"/>
-              <a:gd name="connsiteY4" fmla="*/ 0 h 646331"/>
-              <a:gd name="connsiteX0" fmla="*/ 0 w 16106775"/>
-              <a:gd name="connsiteY0" fmla="*/ 0 h 817781"/>
-              <a:gd name="connsiteX1" fmla="*/ 16106775 w 16106775"/>
-              <a:gd name="connsiteY1" fmla="*/ 0 h 817781"/>
-              <a:gd name="connsiteX2" fmla="*/ 16106775 w 16106775"/>
-              <a:gd name="connsiteY2" fmla="*/ 646331 h 817781"/>
-              <a:gd name="connsiteX3" fmla="*/ 0 w 16106775"/>
-              <a:gd name="connsiteY3" fmla="*/ 817781 h 817781"/>
-              <a:gd name="connsiteX4" fmla="*/ 0 w 16106775"/>
-              <a:gd name="connsiteY4" fmla="*/ 0 h 817781"/>
-              <a:gd name="connsiteX0" fmla="*/ 0 w 16106775"/>
-              <a:gd name="connsiteY0" fmla="*/ 0 h 817781"/>
-              <a:gd name="connsiteX1" fmla="*/ 16106775 w 16106775"/>
-              <a:gd name="connsiteY1" fmla="*/ 0 h 817781"/>
-              <a:gd name="connsiteX2" fmla="*/ 16106775 w 16106775"/>
-              <a:gd name="connsiteY2" fmla="*/ 817781 h 817781"/>
-              <a:gd name="connsiteX3" fmla="*/ 0 w 16106775"/>
-              <a:gd name="connsiteY3" fmla="*/ 817781 h 817781"/>
-              <a:gd name="connsiteX4" fmla="*/ 0 w 16106775"/>
-              <a:gd name="connsiteY4" fmla="*/ 0 h 817781"/>
-              <a:gd name="connsiteX0" fmla="*/ 0 w 16106775"/>
-              <a:gd name="connsiteY0" fmla="*/ 0 h 979756"/>
-              <a:gd name="connsiteX1" fmla="*/ 16106775 w 16106775"/>
-              <a:gd name="connsiteY1" fmla="*/ 0 h 979756"/>
-              <a:gd name="connsiteX2" fmla="*/ 16106775 w 16106775"/>
-              <a:gd name="connsiteY2" fmla="*/ 817781 h 979756"/>
-              <a:gd name="connsiteX3" fmla="*/ 0 w 16106775"/>
-              <a:gd name="connsiteY3" fmla="*/ 979756 h 979756"/>
-              <a:gd name="connsiteX4" fmla="*/ 0 w 16106775"/>
-              <a:gd name="connsiteY4" fmla="*/ 0 h 979756"/>
-              <a:gd name="connsiteX0" fmla="*/ 0 w 16106775"/>
-              <a:gd name="connsiteY0" fmla="*/ 0 h 979756"/>
-              <a:gd name="connsiteX1" fmla="*/ 16106775 w 16106775"/>
-              <a:gd name="connsiteY1" fmla="*/ 0 h 979756"/>
-              <a:gd name="connsiteX2" fmla="*/ 16106775 w 16106775"/>
-              <a:gd name="connsiteY2" fmla="*/ 979756 h 979756"/>
-              <a:gd name="connsiteX3" fmla="*/ 0 w 16106775"/>
-              <a:gd name="connsiteY3" fmla="*/ 979756 h 979756"/>
-              <a:gd name="connsiteX4" fmla="*/ 0 w 16106775"/>
-              <a:gd name="connsiteY4" fmla="*/ 0 h 979756"/>
-              <a:gd name="connsiteX0" fmla="*/ 0 w 16106775"/>
-              <a:gd name="connsiteY0" fmla="*/ 0 h 979756"/>
-              <a:gd name="connsiteX1" fmla="*/ 16106775 w 16106775"/>
-              <a:gd name="connsiteY1" fmla="*/ 0 h 979756"/>
-              <a:gd name="connsiteX2" fmla="*/ 16106775 w 16106775"/>
-              <a:gd name="connsiteY2" fmla="*/ 979756 h 979756"/>
-              <a:gd name="connsiteX3" fmla="*/ 15741 w 16106775"/>
-              <a:gd name="connsiteY3" fmla="*/ 763643 h 979756"/>
-              <a:gd name="connsiteX4" fmla="*/ 0 w 16106775"/>
-              <a:gd name="connsiteY4" fmla="*/ 0 h 979756"/>
-              <a:gd name="connsiteX0" fmla="*/ 0 w 16106775"/>
-              <a:gd name="connsiteY0" fmla="*/ 0 h 763643"/>
-              <a:gd name="connsiteX1" fmla="*/ 16106775 w 16106775"/>
-              <a:gd name="connsiteY1" fmla="*/ 0 h 763643"/>
-              <a:gd name="connsiteX2" fmla="*/ 16091032 w 16106775"/>
-              <a:gd name="connsiteY2" fmla="*/ 750930 h 763643"/>
-              <a:gd name="connsiteX3" fmla="*/ 15741 w 16106775"/>
-              <a:gd name="connsiteY3" fmla="*/ 763643 h 763643"/>
-              <a:gd name="connsiteX4" fmla="*/ 0 w 16106775"/>
-              <a:gd name="connsiteY4" fmla="*/ 0 h 763643"/>
-            </a:gdLst>
-            <a:ahLst/>
-            <a:cxnLst>
-              <a:cxn ang="0">
-                <a:pos x="connsiteX0" y="connsiteY0"/>
-              </a:cxn>
-              <a:cxn ang="0">
-                <a:pos x="connsiteX1" y="connsiteY1"/>
-              </a:cxn>
-              <a:cxn ang="0">
-                <a:pos x="connsiteX2" y="connsiteY2"/>
-              </a:cxn>
-              <a:cxn ang="0">
-                <a:pos x="connsiteX3" y="connsiteY3"/>
-              </a:cxn>
-              <a:cxn ang="0">
-                <a:pos x="connsiteX4" y="connsiteY4"/>
-              </a:cxn>
-            </a:cxnLst>
-            <a:rect l="l" t="t" r="r" b="b"/>
-            <a:pathLst>
-              <a:path w="16106775" h="763643">
-                <a:moveTo>
-                  <a:pt x="0" y="0"/>
-                </a:moveTo>
-                <a:lnTo>
-                  <a:pt x="16106775" y="0"/>
-                </a:lnTo>
-                <a:lnTo>
-                  <a:pt x="16091032" y="750930"/>
-                </a:lnTo>
-                <a:lnTo>
-                  <a:pt x="15741" y="763643"/>
-                </a:lnTo>
-                <a:lnTo>
-                  <a:pt x="0" y="0"/>
-                </a:lnTo>
-                <a:close/>
-              </a:path>
-            </a:pathLst>
-          </a:custGeom>
-          <a:solidFill>
-            <a:schemeClr val="tx1"/>
-          </a:solidFill>
-          <a:ln w="12700" cmpd="sng">
-            <a:noFill/>
-          </a:ln>
-        </p:spPr>
-        <p:txBody>
-          <a:bodyPr wrap="square" tIns="91440" bIns="91440" anchor="ctr">
-            <a:noAutofit/>
-          </a:bodyPr>
-          <a:lstStyle/>
-          <a:p>
-            <a:pPr algn="ctr">
-              <a:defRPr/>
-            </a:pPr>
-            <a:r>
-              <a:rPr lang="en-US" sz="5400" b="1" dirty="0">
-                <a:solidFill>
-                  <a:schemeClr val="bg1"/>
-                </a:solidFill>
-              </a:rPr>
-              <a:t>Objectives</a:t>
-            </a:r>
-          </a:p>
-        </p:txBody>
-      </p:sp>
-      <p:sp>
-        <p:nvSpPr>
-          <p:cNvPr id="17" name="Rectangle 31">
-            <a:extLst>
-              <a:ext uri="{FF2B5EF4-FFF2-40B4-BE49-F238E27FC236}">
-                <a16:creationId xmlns:a16="http://schemas.microsoft.com/office/drawing/2014/main" id="{03452706-DB49-9137-A750-5C994795A387}"/>
-              </a:ext>
-            </a:extLst>
-          </p:cNvPr>
-          <p:cNvSpPr>
-            <a:spLocks noChangeArrowheads="1"/>
-          </p:cNvSpPr>
-          <p:nvPr/>
-        </p:nvSpPr>
-        <p:spPr bwMode="auto">
-          <a:xfrm>
-            <a:off x="1168034" y="5486833"/>
-            <a:ext cx="13461027" cy="13965503"/>
-          </a:xfrm>
-          <a:prstGeom prst="rect">
-            <a:avLst/>
-          </a:prstGeom>
-          <a:solidFill>
-            <a:srgbClr val="E5E5E5"/>
-          </a:solidFill>
-          <a:ln w="12700" cmpd="sng">
-            <a:solidFill>
-              <a:schemeClr val="tx1">
-                <a:lumMod val="75000"/>
-                <a:lumOff val="25000"/>
-              </a:schemeClr>
-            </a:solidFill>
-            <a:miter lim="800000"/>
-            <a:headEnd/>
-            <a:tailEnd/>
-          </a:ln>
-        </p:spPr>
-        <p:txBody>
-          <a:bodyPr wrap="square" anchor="t"/>
-          <a:lstStyle/>
-          <a:p>
-            <a:endParaRPr lang="en-US" sz="4000" baseline="0" dirty="0"/>
-          </a:p>
-        </p:txBody>
-      </p:sp>
-      <p:sp>
-        <p:nvSpPr>
-          <p:cNvPr id="18" name="Rectangle 69">
-            <a:extLst>
-              <a:ext uri="{FF2B5EF4-FFF2-40B4-BE49-F238E27FC236}">
-                <a16:creationId xmlns:a16="http://schemas.microsoft.com/office/drawing/2014/main" id="{00D2EB95-78D6-275E-03CE-E31E9A3C2BEF}"/>
-              </a:ext>
-            </a:extLst>
-          </p:cNvPr>
-          <p:cNvSpPr/>
-          <p:nvPr/>
-        </p:nvSpPr>
-        <p:spPr>
-          <a:xfrm>
-            <a:off x="1168034" y="5486833"/>
-            <a:ext cx="13461027" cy="1368125"/>
-          </a:xfrm>
-          <a:custGeom>
-            <a:avLst/>
-            <a:gdLst>
-              <a:gd name="connsiteX0" fmla="*/ 0 w 16106775"/>
-              <a:gd name="connsiteY0" fmla="*/ 0 h 646331"/>
-              <a:gd name="connsiteX1" fmla="*/ 16106775 w 16106775"/>
-              <a:gd name="connsiteY1" fmla="*/ 0 h 646331"/>
-              <a:gd name="connsiteX2" fmla="*/ 16106775 w 16106775"/>
-              <a:gd name="connsiteY2" fmla="*/ 646331 h 646331"/>
-              <a:gd name="connsiteX3" fmla="*/ 0 w 16106775"/>
-              <a:gd name="connsiteY3" fmla="*/ 646331 h 646331"/>
-              <a:gd name="connsiteX4" fmla="*/ 0 w 16106775"/>
-              <a:gd name="connsiteY4" fmla="*/ 0 h 646331"/>
-              <a:gd name="connsiteX0" fmla="*/ 0 w 16106775"/>
-              <a:gd name="connsiteY0" fmla="*/ 0 h 817781"/>
-              <a:gd name="connsiteX1" fmla="*/ 16106775 w 16106775"/>
-              <a:gd name="connsiteY1" fmla="*/ 0 h 817781"/>
-              <a:gd name="connsiteX2" fmla="*/ 16106775 w 16106775"/>
-              <a:gd name="connsiteY2" fmla="*/ 646331 h 817781"/>
-              <a:gd name="connsiteX3" fmla="*/ 0 w 16106775"/>
-              <a:gd name="connsiteY3" fmla="*/ 817781 h 817781"/>
-              <a:gd name="connsiteX4" fmla="*/ 0 w 16106775"/>
-              <a:gd name="connsiteY4" fmla="*/ 0 h 817781"/>
-              <a:gd name="connsiteX0" fmla="*/ 0 w 16106775"/>
-              <a:gd name="connsiteY0" fmla="*/ 0 h 817781"/>
-              <a:gd name="connsiteX1" fmla="*/ 16106775 w 16106775"/>
-              <a:gd name="connsiteY1" fmla="*/ 0 h 817781"/>
-              <a:gd name="connsiteX2" fmla="*/ 16106775 w 16106775"/>
-              <a:gd name="connsiteY2" fmla="*/ 817781 h 817781"/>
-              <a:gd name="connsiteX3" fmla="*/ 0 w 16106775"/>
-              <a:gd name="connsiteY3" fmla="*/ 817781 h 817781"/>
-              <a:gd name="connsiteX4" fmla="*/ 0 w 16106775"/>
-              <a:gd name="connsiteY4" fmla="*/ 0 h 817781"/>
-              <a:gd name="connsiteX0" fmla="*/ 0 w 16106775"/>
-              <a:gd name="connsiteY0" fmla="*/ 0 h 979756"/>
-              <a:gd name="connsiteX1" fmla="*/ 16106775 w 16106775"/>
-              <a:gd name="connsiteY1" fmla="*/ 0 h 979756"/>
-              <a:gd name="connsiteX2" fmla="*/ 16106775 w 16106775"/>
-              <a:gd name="connsiteY2" fmla="*/ 817781 h 979756"/>
-              <a:gd name="connsiteX3" fmla="*/ 0 w 16106775"/>
-              <a:gd name="connsiteY3" fmla="*/ 979756 h 979756"/>
-              <a:gd name="connsiteX4" fmla="*/ 0 w 16106775"/>
-              <a:gd name="connsiteY4" fmla="*/ 0 h 979756"/>
-              <a:gd name="connsiteX0" fmla="*/ 0 w 16106775"/>
-              <a:gd name="connsiteY0" fmla="*/ 0 h 979756"/>
-              <a:gd name="connsiteX1" fmla="*/ 16106775 w 16106775"/>
-              <a:gd name="connsiteY1" fmla="*/ 0 h 979756"/>
-              <a:gd name="connsiteX2" fmla="*/ 16106775 w 16106775"/>
-              <a:gd name="connsiteY2" fmla="*/ 979756 h 979756"/>
-              <a:gd name="connsiteX3" fmla="*/ 0 w 16106775"/>
-              <a:gd name="connsiteY3" fmla="*/ 979756 h 979756"/>
-              <a:gd name="connsiteX4" fmla="*/ 0 w 16106775"/>
-              <a:gd name="connsiteY4" fmla="*/ 0 h 979756"/>
-              <a:gd name="connsiteX0" fmla="*/ 0 w 16106775"/>
-              <a:gd name="connsiteY0" fmla="*/ 0 h 979756"/>
-              <a:gd name="connsiteX1" fmla="*/ 16106775 w 16106775"/>
-              <a:gd name="connsiteY1" fmla="*/ 0 h 979756"/>
-              <a:gd name="connsiteX2" fmla="*/ 16106775 w 16106775"/>
-              <a:gd name="connsiteY2" fmla="*/ 979756 h 979756"/>
-              <a:gd name="connsiteX3" fmla="*/ 15741 w 16106775"/>
-              <a:gd name="connsiteY3" fmla="*/ 763643 h 979756"/>
-              <a:gd name="connsiteX4" fmla="*/ 0 w 16106775"/>
-              <a:gd name="connsiteY4" fmla="*/ 0 h 979756"/>
-              <a:gd name="connsiteX0" fmla="*/ 0 w 16106775"/>
-              <a:gd name="connsiteY0" fmla="*/ 0 h 763643"/>
-              <a:gd name="connsiteX1" fmla="*/ 16106775 w 16106775"/>
-              <a:gd name="connsiteY1" fmla="*/ 0 h 763643"/>
-              <a:gd name="connsiteX2" fmla="*/ 16091032 w 16106775"/>
-              <a:gd name="connsiteY2" fmla="*/ 750930 h 763643"/>
-              <a:gd name="connsiteX3" fmla="*/ 15741 w 16106775"/>
-              <a:gd name="connsiteY3" fmla="*/ 763643 h 763643"/>
-              <a:gd name="connsiteX4" fmla="*/ 0 w 16106775"/>
-              <a:gd name="connsiteY4" fmla="*/ 0 h 763643"/>
-            </a:gdLst>
-            <a:ahLst/>
-            <a:cxnLst>
-              <a:cxn ang="0">
-                <a:pos x="connsiteX0" y="connsiteY0"/>
-              </a:cxn>
-              <a:cxn ang="0">
-                <a:pos x="connsiteX1" y="connsiteY1"/>
-              </a:cxn>
-              <a:cxn ang="0">
-                <a:pos x="connsiteX2" y="connsiteY2"/>
-              </a:cxn>
-              <a:cxn ang="0">
-                <a:pos x="connsiteX3" y="connsiteY3"/>
-              </a:cxn>
-              <a:cxn ang="0">
-                <a:pos x="connsiteX4" y="connsiteY4"/>
-              </a:cxn>
-            </a:cxnLst>
-            <a:rect l="l" t="t" r="r" b="b"/>
-            <a:pathLst>
-              <a:path w="16106775" h="763643">
-                <a:moveTo>
-                  <a:pt x="0" y="0"/>
-                </a:moveTo>
-                <a:lnTo>
-                  <a:pt x="16106775" y="0"/>
-                </a:lnTo>
-                <a:lnTo>
-                  <a:pt x="16091032" y="750930"/>
-                </a:lnTo>
-                <a:lnTo>
-                  <a:pt x="15741" y="763643"/>
-                </a:lnTo>
-                <a:lnTo>
-                  <a:pt x="0" y="0"/>
-                </a:lnTo>
-                <a:close/>
-              </a:path>
-            </a:pathLst>
-          </a:custGeom>
-          <a:solidFill>
-            <a:schemeClr val="tx1"/>
-          </a:solidFill>
-          <a:ln w="12700" cmpd="sng">
-            <a:noFill/>
-          </a:ln>
-        </p:spPr>
-        <p:txBody>
-          <a:bodyPr wrap="square" tIns="91440" bIns="91440" anchor="ctr">
-            <a:noAutofit/>
-          </a:bodyPr>
-          <a:lstStyle/>
-          <a:p>
-            <a:pPr algn="ctr">
-              <a:defRPr/>
-            </a:pPr>
-            <a:r>
-              <a:rPr lang="en-US" sz="5400" b="1" dirty="0">
-                <a:solidFill>
-                  <a:schemeClr val="bg1"/>
-                </a:solidFill>
-              </a:rPr>
-              <a:t>Abstract/Intro/Motivation</a:t>
-            </a:r>
-          </a:p>
-        </p:txBody>
-      </p:sp>
-      <p:sp>
-        <p:nvSpPr>
-          <p:cNvPr id="19" name="Rectangle 31">
-            <a:extLst>
-              <a:ext uri="{FF2B5EF4-FFF2-40B4-BE49-F238E27FC236}">
-                <a16:creationId xmlns:a16="http://schemas.microsoft.com/office/drawing/2014/main" id="{C9A8357C-D179-CF83-2885-328DA7C9F98D}"/>
-              </a:ext>
-            </a:extLst>
-          </p:cNvPr>
-          <p:cNvSpPr>
-            <a:spLocks noChangeArrowheads="1"/>
-          </p:cNvSpPr>
-          <p:nvPr/>
-        </p:nvSpPr>
-        <p:spPr bwMode="auto">
-          <a:xfrm>
-            <a:off x="1210706" y="20314886"/>
-            <a:ext cx="13461027" cy="11579386"/>
-          </a:xfrm>
-          <a:prstGeom prst="rect">
-            <a:avLst/>
-          </a:prstGeom>
-          <a:solidFill>
-            <a:srgbClr val="E5E5E5"/>
-          </a:solidFill>
-          <a:ln w="12700" cmpd="sng">
-            <a:solidFill>
-              <a:schemeClr val="tx1">
-                <a:lumMod val="75000"/>
-                <a:lumOff val="25000"/>
-              </a:schemeClr>
-            </a:solidFill>
-            <a:miter lim="800000"/>
-            <a:headEnd/>
-            <a:tailEnd/>
-          </a:ln>
-        </p:spPr>
-        <p:txBody>
-          <a:bodyPr wrap="square" anchor="ctr"/>
-          <a:lstStyle/>
-          <a:p>
-            <a:endParaRPr lang="en-US" sz="4000" baseline="0" dirty="0"/>
-          </a:p>
-        </p:txBody>
-      </p:sp>
-      <p:sp>
-        <p:nvSpPr>
-          <p:cNvPr id="20" name="Rectangle 69">
-            <a:extLst>
-              <a:ext uri="{FF2B5EF4-FFF2-40B4-BE49-F238E27FC236}">
-                <a16:creationId xmlns:a16="http://schemas.microsoft.com/office/drawing/2014/main" id="{4C6465AF-C989-03ED-BBAF-4AE87DBE6DD5}"/>
-              </a:ext>
-            </a:extLst>
-          </p:cNvPr>
-          <p:cNvSpPr/>
-          <p:nvPr/>
-        </p:nvSpPr>
-        <p:spPr>
-          <a:xfrm>
-            <a:off x="1210706" y="20210954"/>
-            <a:ext cx="13461027" cy="1544888"/>
-          </a:xfrm>
-          <a:custGeom>
-            <a:avLst/>
-            <a:gdLst>
-              <a:gd name="connsiteX0" fmla="*/ 0 w 16106775"/>
-              <a:gd name="connsiteY0" fmla="*/ 0 h 646331"/>
-              <a:gd name="connsiteX1" fmla="*/ 16106775 w 16106775"/>
-              <a:gd name="connsiteY1" fmla="*/ 0 h 646331"/>
-              <a:gd name="connsiteX2" fmla="*/ 16106775 w 16106775"/>
-              <a:gd name="connsiteY2" fmla="*/ 646331 h 646331"/>
-              <a:gd name="connsiteX3" fmla="*/ 0 w 16106775"/>
-              <a:gd name="connsiteY3" fmla="*/ 646331 h 646331"/>
-              <a:gd name="connsiteX4" fmla="*/ 0 w 16106775"/>
-              <a:gd name="connsiteY4" fmla="*/ 0 h 646331"/>
-              <a:gd name="connsiteX0" fmla="*/ 0 w 16106775"/>
-              <a:gd name="connsiteY0" fmla="*/ 0 h 817781"/>
-              <a:gd name="connsiteX1" fmla="*/ 16106775 w 16106775"/>
-              <a:gd name="connsiteY1" fmla="*/ 0 h 817781"/>
-              <a:gd name="connsiteX2" fmla="*/ 16106775 w 16106775"/>
-              <a:gd name="connsiteY2" fmla="*/ 646331 h 817781"/>
-              <a:gd name="connsiteX3" fmla="*/ 0 w 16106775"/>
-              <a:gd name="connsiteY3" fmla="*/ 817781 h 817781"/>
-              <a:gd name="connsiteX4" fmla="*/ 0 w 16106775"/>
-              <a:gd name="connsiteY4" fmla="*/ 0 h 817781"/>
-              <a:gd name="connsiteX0" fmla="*/ 0 w 16106775"/>
-              <a:gd name="connsiteY0" fmla="*/ 0 h 817781"/>
-              <a:gd name="connsiteX1" fmla="*/ 16106775 w 16106775"/>
-              <a:gd name="connsiteY1" fmla="*/ 0 h 817781"/>
-              <a:gd name="connsiteX2" fmla="*/ 16106775 w 16106775"/>
-              <a:gd name="connsiteY2" fmla="*/ 817781 h 817781"/>
-              <a:gd name="connsiteX3" fmla="*/ 0 w 16106775"/>
-              <a:gd name="connsiteY3" fmla="*/ 817781 h 817781"/>
-              <a:gd name="connsiteX4" fmla="*/ 0 w 16106775"/>
-              <a:gd name="connsiteY4" fmla="*/ 0 h 817781"/>
-              <a:gd name="connsiteX0" fmla="*/ 0 w 16106775"/>
-              <a:gd name="connsiteY0" fmla="*/ 0 h 979756"/>
-              <a:gd name="connsiteX1" fmla="*/ 16106775 w 16106775"/>
-              <a:gd name="connsiteY1" fmla="*/ 0 h 979756"/>
-              <a:gd name="connsiteX2" fmla="*/ 16106775 w 16106775"/>
-              <a:gd name="connsiteY2" fmla="*/ 817781 h 979756"/>
-              <a:gd name="connsiteX3" fmla="*/ 0 w 16106775"/>
-              <a:gd name="connsiteY3" fmla="*/ 979756 h 979756"/>
-              <a:gd name="connsiteX4" fmla="*/ 0 w 16106775"/>
-              <a:gd name="connsiteY4" fmla="*/ 0 h 979756"/>
-              <a:gd name="connsiteX0" fmla="*/ 0 w 16106775"/>
-              <a:gd name="connsiteY0" fmla="*/ 0 h 979756"/>
-              <a:gd name="connsiteX1" fmla="*/ 16106775 w 16106775"/>
-              <a:gd name="connsiteY1" fmla="*/ 0 h 979756"/>
-              <a:gd name="connsiteX2" fmla="*/ 16106775 w 16106775"/>
-              <a:gd name="connsiteY2" fmla="*/ 979756 h 979756"/>
-              <a:gd name="connsiteX3" fmla="*/ 0 w 16106775"/>
-              <a:gd name="connsiteY3" fmla="*/ 979756 h 979756"/>
-              <a:gd name="connsiteX4" fmla="*/ 0 w 16106775"/>
-              <a:gd name="connsiteY4" fmla="*/ 0 h 979756"/>
-              <a:gd name="connsiteX0" fmla="*/ 0 w 16106775"/>
-              <a:gd name="connsiteY0" fmla="*/ 0 h 979756"/>
-              <a:gd name="connsiteX1" fmla="*/ 16106775 w 16106775"/>
-              <a:gd name="connsiteY1" fmla="*/ 0 h 979756"/>
-              <a:gd name="connsiteX2" fmla="*/ 16106775 w 16106775"/>
-              <a:gd name="connsiteY2" fmla="*/ 979756 h 979756"/>
-              <a:gd name="connsiteX3" fmla="*/ 15741 w 16106775"/>
-              <a:gd name="connsiteY3" fmla="*/ 763643 h 979756"/>
-              <a:gd name="connsiteX4" fmla="*/ 0 w 16106775"/>
-              <a:gd name="connsiteY4" fmla="*/ 0 h 979756"/>
-              <a:gd name="connsiteX0" fmla="*/ 0 w 16106775"/>
-              <a:gd name="connsiteY0" fmla="*/ 0 h 763643"/>
-              <a:gd name="connsiteX1" fmla="*/ 16106775 w 16106775"/>
-              <a:gd name="connsiteY1" fmla="*/ 0 h 763643"/>
-              <a:gd name="connsiteX2" fmla="*/ 16091032 w 16106775"/>
-              <a:gd name="connsiteY2" fmla="*/ 750930 h 763643"/>
-              <a:gd name="connsiteX3" fmla="*/ 15741 w 16106775"/>
-              <a:gd name="connsiteY3" fmla="*/ 763643 h 763643"/>
-              <a:gd name="connsiteX4" fmla="*/ 0 w 16106775"/>
-              <a:gd name="connsiteY4" fmla="*/ 0 h 763643"/>
-            </a:gdLst>
-            <a:ahLst/>
-            <a:cxnLst>
-              <a:cxn ang="0">
-                <a:pos x="connsiteX0" y="connsiteY0"/>
-              </a:cxn>
-              <a:cxn ang="0">
-                <a:pos x="connsiteX1" y="connsiteY1"/>
-              </a:cxn>
-              <a:cxn ang="0">
-                <a:pos x="connsiteX2" y="connsiteY2"/>
-              </a:cxn>
-              <a:cxn ang="0">
-                <a:pos x="connsiteX3" y="connsiteY3"/>
-              </a:cxn>
-              <a:cxn ang="0">
-                <a:pos x="connsiteX4" y="connsiteY4"/>
-              </a:cxn>
-            </a:cxnLst>
-            <a:rect l="l" t="t" r="r" b="b"/>
-            <a:pathLst>
-              <a:path w="16106775" h="763643">
-                <a:moveTo>
-                  <a:pt x="0" y="0"/>
-                </a:moveTo>
-                <a:lnTo>
-                  <a:pt x="16106775" y="0"/>
-                </a:lnTo>
-                <a:lnTo>
-                  <a:pt x="16091032" y="750930"/>
-                </a:lnTo>
-                <a:lnTo>
-                  <a:pt x="15741" y="763643"/>
-                </a:lnTo>
-                <a:lnTo>
-                  <a:pt x="0" y="0"/>
-                </a:lnTo>
-                <a:close/>
-              </a:path>
-            </a:pathLst>
-          </a:custGeom>
-          <a:solidFill>
-            <a:schemeClr val="tx1"/>
-          </a:solidFill>
-          <a:ln w="12700" cmpd="sng">
-            <a:noFill/>
-          </a:ln>
-        </p:spPr>
-        <p:txBody>
-          <a:bodyPr wrap="square" tIns="91440" bIns="91440" anchor="ctr">
-            <a:noAutofit/>
-          </a:bodyPr>
-          <a:lstStyle/>
-          <a:p>
-            <a:pPr algn="ctr">
-              <a:defRPr/>
-            </a:pPr>
-            <a:r>
-              <a:rPr lang="en-US" sz="5400" b="1" dirty="0">
-                <a:solidFill>
-                  <a:schemeClr val="bg1"/>
-                </a:solidFill>
-              </a:rPr>
-              <a:t>Background</a:t>
-            </a:r>
-          </a:p>
-        </p:txBody>
-      </p:sp>
-      <p:sp>
-        <p:nvSpPr>
-          <p:cNvPr id="21" name="Rectangle 31">
-            <a:extLst>
-              <a:ext uri="{FF2B5EF4-FFF2-40B4-BE49-F238E27FC236}">
-                <a16:creationId xmlns:a16="http://schemas.microsoft.com/office/drawing/2014/main" id="{E154A7D3-C856-48DE-8B17-7B43FD971C58}"/>
-              </a:ext>
-            </a:extLst>
-          </p:cNvPr>
-          <p:cNvSpPr>
-            <a:spLocks noChangeArrowheads="1"/>
-          </p:cNvSpPr>
-          <p:nvPr/>
-        </p:nvSpPr>
-        <p:spPr bwMode="auto">
-          <a:xfrm>
-            <a:off x="29237423" y="5486833"/>
-            <a:ext cx="13461028" cy="18420259"/>
-          </a:xfrm>
-          <a:prstGeom prst="rect">
-            <a:avLst/>
-          </a:prstGeom>
-          <a:solidFill>
-            <a:srgbClr val="E5E5E5"/>
-          </a:solidFill>
-          <a:ln w="12700" cmpd="sng">
-            <a:solidFill>
-              <a:schemeClr val="tx1">
-                <a:lumMod val="75000"/>
-                <a:lumOff val="25000"/>
-              </a:schemeClr>
-            </a:solidFill>
-            <a:miter lim="800000"/>
-            <a:headEnd/>
-            <a:tailEnd/>
-          </a:ln>
-        </p:spPr>
-        <p:txBody>
-          <a:bodyPr wrap="square" anchor="t"/>
-          <a:lstStyle/>
-          <a:p>
-            <a:endParaRPr lang="en-US" sz="4000" baseline="0" dirty="0"/>
-          </a:p>
-        </p:txBody>
-      </p:sp>
-      <p:sp>
-        <p:nvSpPr>
-          <p:cNvPr id="22" name="Rectangle 69">
-            <a:extLst>
-              <a:ext uri="{FF2B5EF4-FFF2-40B4-BE49-F238E27FC236}">
-                <a16:creationId xmlns:a16="http://schemas.microsoft.com/office/drawing/2014/main" id="{837E3D02-869E-9EA2-64F2-717528662C50}"/>
-              </a:ext>
-            </a:extLst>
-          </p:cNvPr>
-          <p:cNvSpPr/>
-          <p:nvPr/>
-        </p:nvSpPr>
-        <p:spPr>
-          <a:xfrm>
-            <a:off x="29224224" y="5486833"/>
-            <a:ext cx="13498942" cy="1368125"/>
-          </a:xfrm>
-          <a:custGeom>
-            <a:avLst/>
-            <a:gdLst>
-              <a:gd name="connsiteX0" fmla="*/ 0 w 16106775"/>
-              <a:gd name="connsiteY0" fmla="*/ 0 h 646331"/>
-              <a:gd name="connsiteX1" fmla="*/ 16106775 w 16106775"/>
-              <a:gd name="connsiteY1" fmla="*/ 0 h 646331"/>
-              <a:gd name="connsiteX2" fmla="*/ 16106775 w 16106775"/>
-              <a:gd name="connsiteY2" fmla="*/ 646331 h 646331"/>
-              <a:gd name="connsiteX3" fmla="*/ 0 w 16106775"/>
-              <a:gd name="connsiteY3" fmla="*/ 646331 h 646331"/>
-              <a:gd name="connsiteX4" fmla="*/ 0 w 16106775"/>
-              <a:gd name="connsiteY4" fmla="*/ 0 h 646331"/>
-              <a:gd name="connsiteX0" fmla="*/ 0 w 16106775"/>
-              <a:gd name="connsiteY0" fmla="*/ 0 h 817781"/>
-              <a:gd name="connsiteX1" fmla="*/ 16106775 w 16106775"/>
-              <a:gd name="connsiteY1" fmla="*/ 0 h 817781"/>
-              <a:gd name="connsiteX2" fmla="*/ 16106775 w 16106775"/>
-              <a:gd name="connsiteY2" fmla="*/ 646331 h 817781"/>
-              <a:gd name="connsiteX3" fmla="*/ 0 w 16106775"/>
-              <a:gd name="connsiteY3" fmla="*/ 817781 h 817781"/>
-              <a:gd name="connsiteX4" fmla="*/ 0 w 16106775"/>
-              <a:gd name="connsiteY4" fmla="*/ 0 h 817781"/>
-              <a:gd name="connsiteX0" fmla="*/ 0 w 16106775"/>
-              <a:gd name="connsiteY0" fmla="*/ 0 h 817781"/>
-              <a:gd name="connsiteX1" fmla="*/ 16106775 w 16106775"/>
-              <a:gd name="connsiteY1" fmla="*/ 0 h 817781"/>
-              <a:gd name="connsiteX2" fmla="*/ 16106775 w 16106775"/>
-              <a:gd name="connsiteY2" fmla="*/ 817781 h 817781"/>
-              <a:gd name="connsiteX3" fmla="*/ 0 w 16106775"/>
-              <a:gd name="connsiteY3" fmla="*/ 817781 h 817781"/>
-              <a:gd name="connsiteX4" fmla="*/ 0 w 16106775"/>
-              <a:gd name="connsiteY4" fmla="*/ 0 h 817781"/>
-              <a:gd name="connsiteX0" fmla="*/ 0 w 16106775"/>
-              <a:gd name="connsiteY0" fmla="*/ 0 h 979756"/>
-              <a:gd name="connsiteX1" fmla="*/ 16106775 w 16106775"/>
-              <a:gd name="connsiteY1" fmla="*/ 0 h 979756"/>
-              <a:gd name="connsiteX2" fmla="*/ 16106775 w 16106775"/>
-              <a:gd name="connsiteY2" fmla="*/ 817781 h 979756"/>
-              <a:gd name="connsiteX3" fmla="*/ 0 w 16106775"/>
-              <a:gd name="connsiteY3" fmla="*/ 979756 h 979756"/>
-              <a:gd name="connsiteX4" fmla="*/ 0 w 16106775"/>
-              <a:gd name="connsiteY4" fmla="*/ 0 h 979756"/>
-              <a:gd name="connsiteX0" fmla="*/ 0 w 16106775"/>
-              <a:gd name="connsiteY0" fmla="*/ 0 h 979756"/>
-              <a:gd name="connsiteX1" fmla="*/ 16106775 w 16106775"/>
-              <a:gd name="connsiteY1" fmla="*/ 0 h 979756"/>
-              <a:gd name="connsiteX2" fmla="*/ 16106775 w 16106775"/>
-              <a:gd name="connsiteY2" fmla="*/ 979756 h 979756"/>
-              <a:gd name="connsiteX3" fmla="*/ 0 w 16106775"/>
-              <a:gd name="connsiteY3" fmla="*/ 979756 h 979756"/>
-              <a:gd name="connsiteX4" fmla="*/ 0 w 16106775"/>
-              <a:gd name="connsiteY4" fmla="*/ 0 h 979756"/>
-              <a:gd name="connsiteX0" fmla="*/ 0 w 16106775"/>
-              <a:gd name="connsiteY0" fmla="*/ 0 h 979756"/>
-              <a:gd name="connsiteX1" fmla="*/ 16106775 w 16106775"/>
-              <a:gd name="connsiteY1" fmla="*/ 0 h 979756"/>
-              <a:gd name="connsiteX2" fmla="*/ 16106775 w 16106775"/>
-              <a:gd name="connsiteY2" fmla="*/ 979756 h 979756"/>
-              <a:gd name="connsiteX3" fmla="*/ 15741 w 16106775"/>
-              <a:gd name="connsiteY3" fmla="*/ 763643 h 979756"/>
-              <a:gd name="connsiteX4" fmla="*/ 0 w 16106775"/>
-              <a:gd name="connsiteY4" fmla="*/ 0 h 979756"/>
-              <a:gd name="connsiteX0" fmla="*/ 0 w 16106775"/>
-              <a:gd name="connsiteY0" fmla="*/ 0 h 763643"/>
-              <a:gd name="connsiteX1" fmla="*/ 16106775 w 16106775"/>
-              <a:gd name="connsiteY1" fmla="*/ 0 h 763643"/>
-              <a:gd name="connsiteX2" fmla="*/ 16091032 w 16106775"/>
-              <a:gd name="connsiteY2" fmla="*/ 750930 h 763643"/>
-              <a:gd name="connsiteX3" fmla="*/ 15741 w 16106775"/>
-              <a:gd name="connsiteY3" fmla="*/ 763643 h 763643"/>
-              <a:gd name="connsiteX4" fmla="*/ 0 w 16106775"/>
-              <a:gd name="connsiteY4" fmla="*/ 0 h 763643"/>
-            </a:gdLst>
-            <a:ahLst/>
-            <a:cxnLst>
-              <a:cxn ang="0">
-                <a:pos x="connsiteX0" y="connsiteY0"/>
-              </a:cxn>
-              <a:cxn ang="0">
-                <a:pos x="connsiteX1" y="connsiteY1"/>
-              </a:cxn>
-              <a:cxn ang="0">
-                <a:pos x="connsiteX2" y="connsiteY2"/>
-              </a:cxn>
-              <a:cxn ang="0">
-                <a:pos x="connsiteX3" y="connsiteY3"/>
-              </a:cxn>
-              <a:cxn ang="0">
-                <a:pos x="connsiteX4" y="connsiteY4"/>
-              </a:cxn>
-            </a:cxnLst>
-            <a:rect l="l" t="t" r="r" b="b"/>
-            <a:pathLst>
-              <a:path w="16106775" h="763643">
-                <a:moveTo>
-                  <a:pt x="0" y="0"/>
-                </a:moveTo>
-                <a:lnTo>
-                  <a:pt x="16106775" y="0"/>
-                </a:lnTo>
-                <a:lnTo>
-                  <a:pt x="16091032" y="750930"/>
-                </a:lnTo>
-                <a:lnTo>
-                  <a:pt x="15741" y="763643"/>
-                </a:lnTo>
-                <a:lnTo>
-                  <a:pt x="0" y="0"/>
-                </a:lnTo>
-                <a:close/>
-              </a:path>
-            </a:pathLst>
-          </a:custGeom>
-          <a:solidFill>
-            <a:schemeClr val="tx1"/>
-          </a:solidFill>
-          <a:ln w="12700" cmpd="sng">
-            <a:noFill/>
-          </a:ln>
-        </p:spPr>
-        <p:txBody>
-          <a:bodyPr wrap="square" tIns="91440" bIns="91440" anchor="ctr">
-            <a:noAutofit/>
-          </a:bodyPr>
-          <a:lstStyle/>
-          <a:p>
-            <a:pPr algn="ctr">
-              <a:defRPr/>
-            </a:pPr>
-            <a:r>
-              <a:rPr lang="en-US" sz="5400" b="1" dirty="0">
-                <a:solidFill>
-                  <a:schemeClr val="bg1"/>
-                </a:solidFill>
-              </a:rPr>
-              <a:t>Results/Discussion</a:t>
-            </a:r>
-          </a:p>
-        </p:txBody>
-      </p:sp>
-      <p:sp>
-        <p:nvSpPr>
-          <p:cNvPr id="23" name="Rectangle 31">
-            <a:extLst>
-              <a:ext uri="{FF2B5EF4-FFF2-40B4-BE49-F238E27FC236}">
-                <a16:creationId xmlns:a16="http://schemas.microsoft.com/office/drawing/2014/main" id="{A898850E-292E-B7DC-DCE9-541A021C0273}"/>
-              </a:ext>
-            </a:extLst>
-          </p:cNvPr>
-          <p:cNvSpPr>
-            <a:spLocks noChangeArrowheads="1"/>
-          </p:cNvSpPr>
-          <p:nvPr/>
-        </p:nvSpPr>
-        <p:spPr bwMode="auto">
-          <a:xfrm>
-            <a:off x="29262139" y="24740990"/>
-            <a:ext cx="13461027" cy="7153282"/>
-          </a:xfrm>
-          <a:prstGeom prst="rect">
-            <a:avLst/>
-          </a:prstGeom>
-          <a:solidFill>
-            <a:srgbClr val="E5E5E5"/>
-          </a:solidFill>
-          <a:ln w="12700" cmpd="sng">
-            <a:solidFill>
-              <a:schemeClr val="tx1">
-                <a:lumMod val="75000"/>
-                <a:lumOff val="25000"/>
-              </a:schemeClr>
-            </a:solidFill>
-            <a:miter lim="800000"/>
-            <a:headEnd/>
-            <a:tailEnd/>
-          </a:ln>
-        </p:spPr>
-        <p:txBody>
-          <a:bodyPr wrap="square" anchor="ctr"/>
-          <a:lstStyle/>
-          <a:p>
-            <a:endParaRPr lang="en-US" sz="4000" baseline="0" dirty="0"/>
-          </a:p>
-        </p:txBody>
-      </p:sp>
-      <p:sp>
-        <p:nvSpPr>
-          <p:cNvPr id="24" name="Rectangle 69">
-            <a:extLst>
-              <a:ext uri="{FF2B5EF4-FFF2-40B4-BE49-F238E27FC236}">
-                <a16:creationId xmlns:a16="http://schemas.microsoft.com/office/drawing/2014/main" id="{7A6A1E2D-0496-928C-A1E3-B056C81E5F07}"/>
-              </a:ext>
-            </a:extLst>
-          </p:cNvPr>
-          <p:cNvSpPr/>
-          <p:nvPr/>
-        </p:nvSpPr>
-        <p:spPr>
-          <a:xfrm>
-            <a:off x="29262139" y="24637057"/>
-            <a:ext cx="13461027" cy="1368125"/>
-          </a:xfrm>
-          <a:custGeom>
-            <a:avLst/>
-            <a:gdLst>
-              <a:gd name="connsiteX0" fmla="*/ 0 w 16106775"/>
-              <a:gd name="connsiteY0" fmla="*/ 0 h 646331"/>
-              <a:gd name="connsiteX1" fmla="*/ 16106775 w 16106775"/>
-              <a:gd name="connsiteY1" fmla="*/ 0 h 646331"/>
-              <a:gd name="connsiteX2" fmla="*/ 16106775 w 16106775"/>
-              <a:gd name="connsiteY2" fmla="*/ 646331 h 646331"/>
-              <a:gd name="connsiteX3" fmla="*/ 0 w 16106775"/>
-              <a:gd name="connsiteY3" fmla="*/ 646331 h 646331"/>
-              <a:gd name="connsiteX4" fmla="*/ 0 w 16106775"/>
-              <a:gd name="connsiteY4" fmla="*/ 0 h 646331"/>
-              <a:gd name="connsiteX0" fmla="*/ 0 w 16106775"/>
-              <a:gd name="connsiteY0" fmla="*/ 0 h 817781"/>
-              <a:gd name="connsiteX1" fmla="*/ 16106775 w 16106775"/>
-              <a:gd name="connsiteY1" fmla="*/ 0 h 817781"/>
-              <a:gd name="connsiteX2" fmla="*/ 16106775 w 16106775"/>
-              <a:gd name="connsiteY2" fmla="*/ 646331 h 817781"/>
-              <a:gd name="connsiteX3" fmla="*/ 0 w 16106775"/>
-              <a:gd name="connsiteY3" fmla="*/ 817781 h 817781"/>
-              <a:gd name="connsiteX4" fmla="*/ 0 w 16106775"/>
-              <a:gd name="connsiteY4" fmla="*/ 0 h 817781"/>
-              <a:gd name="connsiteX0" fmla="*/ 0 w 16106775"/>
-              <a:gd name="connsiteY0" fmla="*/ 0 h 817781"/>
-              <a:gd name="connsiteX1" fmla="*/ 16106775 w 16106775"/>
-              <a:gd name="connsiteY1" fmla="*/ 0 h 817781"/>
-              <a:gd name="connsiteX2" fmla="*/ 16106775 w 16106775"/>
-              <a:gd name="connsiteY2" fmla="*/ 817781 h 817781"/>
-              <a:gd name="connsiteX3" fmla="*/ 0 w 16106775"/>
-              <a:gd name="connsiteY3" fmla="*/ 817781 h 817781"/>
-              <a:gd name="connsiteX4" fmla="*/ 0 w 16106775"/>
-              <a:gd name="connsiteY4" fmla="*/ 0 h 817781"/>
-              <a:gd name="connsiteX0" fmla="*/ 0 w 16106775"/>
-              <a:gd name="connsiteY0" fmla="*/ 0 h 979756"/>
-              <a:gd name="connsiteX1" fmla="*/ 16106775 w 16106775"/>
-              <a:gd name="connsiteY1" fmla="*/ 0 h 979756"/>
-              <a:gd name="connsiteX2" fmla="*/ 16106775 w 16106775"/>
-              <a:gd name="connsiteY2" fmla="*/ 817781 h 979756"/>
-              <a:gd name="connsiteX3" fmla="*/ 0 w 16106775"/>
-              <a:gd name="connsiteY3" fmla="*/ 979756 h 979756"/>
-              <a:gd name="connsiteX4" fmla="*/ 0 w 16106775"/>
-              <a:gd name="connsiteY4" fmla="*/ 0 h 979756"/>
-              <a:gd name="connsiteX0" fmla="*/ 0 w 16106775"/>
-              <a:gd name="connsiteY0" fmla="*/ 0 h 979756"/>
-              <a:gd name="connsiteX1" fmla="*/ 16106775 w 16106775"/>
-              <a:gd name="connsiteY1" fmla="*/ 0 h 979756"/>
-              <a:gd name="connsiteX2" fmla="*/ 16106775 w 16106775"/>
-              <a:gd name="connsiteY2" fmla="*/ 979756 h 979756"/>
-              <a:gd name="connsiteX3" fmla="*/ 0 w 16106775"/>
-              <a:gd name="connsiteY3" fmla="*/ 979756 h 979756"/>
-              <a:gd name="connsiteX4" fmla="*/ 0 w 16106775"/>
-              <a:gd name="connsiteY4" fmla="*/ 0 h 979756"/>
-              <a:gd name="connsiteX0" fmla="*/ 0 w 16106775"/>
-              <a:gd name="connsiteY0" fmla="*/ 0 h 979756"/>
-              <a:gd name="connsiteX1" fmla="*/ 16106775 w 16106775"/>
-              <a:gd name="connsiteY1" fmla="*/ 0 h 979756"/>
-              <a:gd name="connsiteX2" fmla="*/ 16106775 w 16106775"/>
-              <a:gd name="connsiteY2" fmla="*/ 979756 h 979756"/>
-              <a:gd name="connsiteX3" fmla="*/ 15741 w 16106775"/>
-              <a:gd name="connsiteY3" fmla="*/ 763643 h 979756"/>
-              <a:gd name="connsiteX4" fmla="*/ 0 w 16106775"/>
-              <a:gd name="connsiteY4" fmla="*/ 0 h 979756"/>
-              <a:gd name="connsiteX0" fmla="*/ 0 w 16106775"/>
-              <a:gd name="connsiteY0" fmla="*/ 0 h 763643"/>
-              <a:gd name="connsiteX1" fmla="*/ 16106775 w 16106775"/>
-              <a:gd name="connsiteY1" fmla="*/ 0 h 763643"/>
-              <a:gd name="connsiteX2" fmla="*/ 16091032 w 16106775"/>
-              <a:gd name="connsiteY2" fmla="*/ 750930 h 763643"/>
-              <a:gd name="connsiteX3" fmla="*/ 15741 w 16106775"/>
-              <a:gd name="connsiteY3" fmla="*/ 763643 h 763643"/>
-              <a:gd name="connsiteX4" fmla="*/ 0 w 16106775"/>
-              <a:gd name="connsiteY4" fmla="*/ 0 h 763643"/>
-            </a:gdLst>
-            <a:ahLst/>
-            <a:cxnLst>
-              <a:cxn ang="0">
-                <a:pos x="connsiteX0" y="connsiteY0"/>
-              </a:cxn>
-              <a:cxn ang="0">
-                <a:pos x="connsiteX1" y="connsiteY1"/>
-              </a:cxn>
-              <a:cxn ang="0">
-                <a:pos x="connsiteX2" y="connsiteY2"/>
-              </a:cxn>
-              <a:cxn ang="0">
-                <a:pos x="connsiteX3" y="connsiteY3"/>
-              </a:cxn>
-              <a:cxn ang="0">
-                <a:pos x="connsiteX4" y="connsiteY4"/>
-              </a:cxn>
-            </a:cxnLst>
-            <a:rect l="l" t="t" r="r" b="b"/>
-            <a:pathLst>
-              <a:path w="16106775" h="763643">
-                <a:moveTo>
-                  <a:pt x="0" y="0"/>
-                </a:moveTo>
-                <a:lnTo>
-                  <a:pt x="16106775" y="0"/>
-                </a:lnTo>
-                <a:lnTo>
-                  <a:pt x="16091032" y="750930"/>
-                </a:lnTo>
-                <a:lnTo>
-                  <a:pt x="15741" y="763643"/>
-                </a:lnTo>
-                <a:lnTo>
-                  <a:pt x="0" y="0"/>
-                </a:lnTo>
-                <a:close/>
-              </a:path>
-            </a:pathLst>
-          </a:custGeom>
-          <a:solidFill>
-            <a:schemeClr val="tx1"/>
-          </a:solidFill>
-          <a:ln w="12700" cmpd="sng">
-            <a:noFill/>
-          </a:ln>
-        </p:spPr>
-        <p:txBody>
-          <a:bodyPr wrap="square" tIns="91440" bIns="91440" anchor="ctr">
-            <a:noAutofit/>
-          </a:bodyPr>
-          <a:lstStyle/>
-          <a:p>
-            <a:pPr algn="ctr">
-              <a:defRPr/>
-            </a:pPr>
-            <a:r>
-              <a:rPr lang="en-US" sz="5400" b="1" dirty="0">
-                <a:solidFill>
-                  <a:schemeClr val="bg1"/>
-                </a:solidFill>
-              </a:rPr>
-              <a:t>Future Direction</a:t>
-            </a:r>
-          </a:p>
-        </p:txBody>
-      </p:sp>
-      <p:sp>
-        <p:nvSpPr>
-          <p:cNvPr id="25" name="Rectangle 31">
-            <a:extLst>
-              <a:ext uri="{FF2B5EF4-FFF2-40B4-BE49-F238E27FC236}">
-                <a16:creationId xmlns:a16="http://schemas.microsoft.com/office/drawing/2014/main" id="{CE113A2C-7F71-C560-DCF4-6F206A5F3E05}"/>
-              </a:ext>
-            </a:extLst>
-          </p:cNvPr>
-          <p:cNvSpPr>
-            <a:spLocks noChangeArrowheads="1"/>
-          </p:cNvSpPr>
-          <p:nvPr/>
-        </p:nvSpPr>
-        <p:spPr bwMode="auto">
-          <a:xfrm>
-            <a:off x="15227630" y="13034102"/>
-            <a:ext cx="13461027" cy="18860170"/>
-          </a:xfrm>
-          <a:prstGeom prst="rect">
-            <a:avLst/>
-          </a:prstGeom>
-          <a:solidFill>
-            <a:srgbClr val="E5E5E5"/>
-          </a:solidFill>
-          <a:ln w="12700" cmpd="sng">
-            <a:solidFill>
-              <a:schemeClr val="tx1">
-                <a:lumMod val="75000"/>
-                <a:lumOff val="25000"/>
-              </a:schemeClr>
-            </a:solidFill>
-            <a:miter lim="800000"/>
-            <a:headEnd/>
-            <a:tailEnd/>
-          </a:ln>
-        </p:spPr>
-        <p:txBody>
-          <a:bodyPr wrap="square" anchor="ctr"/>
-          <a:lstStyle/>
-          <a:p>
-            <a:endParaRPr lang="en-US" sz="4000" baseline="0" dirty="0"/>
-          </a:p>
-        </p:txBody>
-      </p:sp>
-      <p:sp>
-        <p:nvSpPr>
-          <p:cNvPr id="26" name="Rectangle 69">
-            <a:extLst>
-              <a:ext uri="{FF2B5EF4-FFF2-40B4-BE49-F238E27FC236}">
-                <a16:creationId xmlns:a16="http://schemas.microsoft.com/office/drawing/2014/main" id="{BA59A105-7C19-39B9-0588-A12C7D1FC712}"/>
-              </a:ext>
-            </a:extLst>
-          </p:cNvPr>
-          <p:cNvSpPr/>
-          <p:nvPr/>
-        </p:nvSpPr>
-        <p:spPr>
-          <a:xfrm>
-            <a:off x="15227630" y="12930170"/>
-            <a:ext cx="13461027" cy="1368125"/>
-          </a:xfrm>
-          <a:custGeom>
-            <a:avLst/>
-            <a:gdLst>
-              <a:gd name="connsiteX0" fmla="*/ 0 w 16106775"/>
-              <a:gd name="connsiteY0" fmla="*/ 0 h 646331"/>
-              <a:gd name="connsiteX1" fmla="*/ 16106775 w 16106775"/>
-              <a:gd name="connsiteY1" fmla="*/ 0 h 646331"/>
-              <a:gd name="connsiteX2" fmla="*/ 16106775 w 16106775"/>
-              <a:gd name="connsiteY2" fmla="*/ 646331 h 646331"/>
-              <a:gd name="connsiteX3" fmla="*/ 0 w 16106775"/>
-              <a:gd name="connsiteY3" fmla="*/ 646331 h 646331"/>
-              <a:gd name="connsiteX4" fmla="*/ 0 w 16106775"/>
-              <a:gd name="connsiteY4" fmla="*/ 0 h 646331"/>
-              <a:gd name="connsiteX0" fmla="*/ 0 w 16106775"/>
-              <a:gd name="connsiteY0" fmla="*/ 0 h 817781"/>
-              <a:gd name="connsiteX1" fmla="*/ 16106775 w 16106775"/>
-              <a:gd name="connsiteY1" fmla="*/ 0 h 817781"/>
-              <a:gd name="connsiteX2" fmla="*/ 16106775 w 16106775"/>
-              <a:gd name="connsiteY2" fmla="*/ 646331 h 817781"/>
-              <a:gd name="connsiteX3" fmla="*/ 0 w 16106775"/>
-              <a:gd name="connsiteY3" fmla="*/ 817781 h 817781"/>
-              <a:gd name="connsiteX4" fmla="*/ 0 w 16106775"/>
-              <a:gd name="connsiteY4" fmla="*/ 0 h 817781"/>
-              <a:gd name="connsiteX0" fmla="*/ 0 w 16106775"/>
-              <a:gd name="connsiteY0" fmla="*/ 0 h 817781"/>
-              <a:gd name="connsiteX1" fmla="*/ 16106775 w 16106775"/>
-              <a:gd name="connsiteY1" fmla="*/ 0 h 817781"/>
-              <a:gd name="connsiteX2" fmla="*/ 16106775 w 16106775"/>
-              <a:gd name="connsiteY2" fmla="*/ 817781 h 817781"/>
-              <a:gd name="connsiteX3" fmla="*/ 0 w 16106775"/>
-              <a:gd name="connsiteY3" fmla="*/ 817781 h 817781"/>
-              <a:gd name="connsiteX4" fmla="*/ 0 w 16106775"/>
-              <a:gd name="connsiteY4" fmla="*/ 0 h 817781"/>
-              <a:gd name="connsiteX0" fmla="*/ 0 w 16106775"/>
-              <a:gd name="connsiteY0" fmla="*/ 0 h 979756"/>
-              <a:gd name="connsiteX1" fmla="*/ 16106775 w 16106775"/>
-              <a:gd name="connsiteY1" fmla="*/ 0 h 979756"/>
-              <a:gd name="connsiteX2" fmla="*/ 16106775 w 16106775"/>
-              <a:gd name="connsiteY2" fmla="*/ 817781 h 979756"/>
-              <a:gd name="connsiteX3" fmla="*/ 0 w 16106775"/>
-              <a:gd name="connsiteY3" fmla="*/ 979756 h 979756"/>
-              <a:gd name="connsiteX4" fmla="*/ 0 w 16106775"/>
-              <a:gd name="connsiteY4" fmla="*/ 0 h 979756"/>
-              <a:gd name="connsiteX0" fmla="*/ 0 w 16106775"/>
-              <a:gd name="connsiteY0" fmla="*/ 0 h 979756"/>
-              <a:gd name="connsiteX1" fmla="*/ 16106775 w 16106775"/>
-              <a:gd name="connsiteY1" fmla="*/ 0 h 979756"/>
-              <a:gd name="connsiteX2" fmla="*/ 16106775 w 16106775"/>
-              <a:gd name="connsiteY2" fmla="*/ 979756 h 979756"/>
-              <a:gd name="connsiteX3" fmla="*/ 0 w 16106775"/>
-              <a:gd name="connsiteY3" fmla="*/ 979756 h 979756"/>
-              <a:gd name="connsiteX4" fmla="*/ 0 w 16106775"/>
-              <a:gd name="connsiteY4" fmla="*/ 0 h 979756"/>
-              <a:gd name="connsiteX0" fmla="*/ 0 w 16106775"/>
-              <a:gd name="connsiteY0" fmla="*/ 0 h 979756"/>
-              <a:gd name="connsiteX1" fmla="*/ 16106775 w 16106775"/>
-              <a:gd name="connsiteY1" fmla="*/ 0 h 979756"/>
-              <a:gd name="connsiteX2" fmla="*/ 16106775 w 16106775"/>
-              <a:gd name="connsiteY2" fmla="*/ 979756 h 979756"/>
-              <a:gd name="connsiteX3" fmla="*/ 15741 w 16106775"/>
-              <a:gd name="connsiteY3" fmla="*/ 763643 h 979756"/>
-              <a:gd name="connsiteX4" fmla="*/ 0 w 16106775"/>
-              <a:gd name="connsiteY4" fmla="*/ 0 h 979756"/>
-              <a:gd name="connsiteX0" fmla="*/ 0 w 16106775"/>
-              <a:gd name="connsiteY0" fmla="*/ 0 h 763643"/>
-              <a:gd name="connsiteX1" fmla="*/ 16106775 w 16106775"/>
-              <a:gd name="connsiteY1" fmla="*/ 0 h 763643"/>
-              <a:gd name="connsiteX2" fmla="*/ 16091032 w 16106775"/>
-              <a:gd name="connsiteY2" fmla="*/ 750930 h 763643"/>
-              <a:gd name="connsiteX3" fmla="*/ 15741 w 16106775"/>
-              <a:gd name="connsiteY3" fmla="*/ 763643 h 763643"/>
-              <a:gd name="connsiteX4" fmla="*/ 0 w 16106775"/>
-              <a:gd name="connsiteY4" fmla="*/ 0 h 763643"/>
-            </a:gdLst>
-            <a:ahLst/>
-            <a:cxnLst>
-              <a:cxn ang="0">
-                <a:pos x="connsiteX0" y="connsiteY0"/>
-              </a:cxn>
-              <a:cxn ang="0">
-                <a:pos x="connsiteX1" y="connsiteY1"/>
-              </a:cxn>
-              <a:cxn ang="0">
-                <a:pos x="connsiteX2" y="connsiteY2"/>
-              </a:cxn>
-              <a:cxn ang="0">
-                <a:pos x="connsiteX3" y="connsiteY3"/>
-              </a:cxn>
-              <a:cxn ang="0">
-                <a:pos x="connsiteX4" y="connsiteY4"/>
-              </a:cxn>
-            </a:cxnLst>
-            <a:rect l="l" t="t" r="r" b="b"/>
-            <a:pathLst>
-              <a:path w="16106775" h="763643">
-                <a:moveTo>
-                  <a:pt x="0" y="0"/>
-                </a:moveTo>
-                <a:lnTo>
-                  <a:pt x="16106775" y="0"/>
-                </a:lnTo>
-                <a:lnTo>
-                  <a:pt x="16091032" y="750930"/>
-                </a:lnTo>
-                <a:lnTo>
-                  <a:pt x="15741" y="763643"/>
-                </a:lnTo>
-                <a:lnTo>
-                  <a:pt x="0" y="0"/>
-                </a:lnTo>
-                <a:close/>
-              </a:path>
-            </a:pathLst>
-          </a:custGeom>
-          <a:solidFill>
-            <a:schemeClr val="tx1"/>
-          </a:solidFill>
-          <a:ln w="12700" cmpd="sng">
-            <a:noFill/>
-          </a:ln>
-        </p:spPr>
-        <p:txBody>
-          <a:bodyPr wrap="square" tIns="91440" bIns="91440" anchor="ctr">
-            <a:noAutofit/>
-          </a:bodyPr>
-          <a:lstStyle/>
-          <a:p>
-            <a:pPr algn="ctr">
-              <a:defRPr/>
-            </a:pPr>
-            <a:r>
-              <a:rPr lang="en-US" sz="5400" b="1" dirty="0">
-                <a:solidFill>
-                  <a:schemeClr val="bg1"/>
-                </a:solidFill>
-              </a:rPr>
-              <a:t>Methods</a:t>
-            </a:r>
-          </a:p>
-        </p:txBody>
-      </p:sp>
-      <p:sp>
-        <p:nvSpPr>
-          <p:cNvPr id="3" name="TextBox 2">
-            <a:extLst>
-              <a:ext uri="{FF2B5EF4-FFF2-40B4-BE49-F238E27FC236}">
-                <a16:creationId xmlns:a16="http://schemas.microsoft.com/office/drawing/2014/main" id="{90DB3438-10A4-FDF5-76E1-D71E01979CD8}"/>
-              </a:ext>
-            </a:extLst>
-          </p:cNvPr>
-          <p:cNvSpPr txBox="1"/>
-          <p:nvPr/>
-        </p:nvSpPr>
-        <p:spPr>
-          <a:xfrm>
-            <a:off x="1527472" y="7311605"/>
-            <a:ext cx="12750799" cy="603941"/>
-          </a:xfrm>
-          <a:prstGeom prst="rect">
-            <a:avLst/>
-          </a:prstGeom>
-          <a:noFill/>
-        </p:spPr>
-        <p:txBody>
-          <a:bodyPr wrap="square" lIns="79925" tIns="39970" rIns="79925" bIns="39970" rtlCol="0">
-            <a:spAutoFit/>
-          </a:bodyPr>
-          <a:lstStyle/>
-          <a:p>
-            <a:r>
-              <a:rPr lang="en-US" sz="3400" b="0" baseline="0" dirty="0">
-                <a:latin typeface="Calibri" panose="020F0502020204030204" pitchFamily="34" charset="0"/>
-              </a:rPr>
-              <a:t>Insert abstract here</a:t>
-            </a:r>
-          </a:p>
-        </p:txBody>
-      </p:sp>
-      <p:sp>
-        <p:nvSpPr>
-          <p:cNvPr id="5" name="TextBox 4">
-            <a:extLst>
-              <a:ext uri="{FF2B5EF4-FFF2-40B4-BE49-F238E27FC236}">
-                <a16:creationId xmlns:a16="http://schemas.microsoft.com/office/drawing/2014/main" id="{BDD5B95A-AE6B-ECE6-106B-E43F142FF6D4}"/>
-              </a:ext>
-            </a:extLst>
-          </p:cNvPr>
-          <p:cNvSpPr txBox="1"/>
-          <p:nvPr/>
-        </p:nvSpPr>
-        <p:spPr>
-          <a:xfrm>
-            <a:off x="15548272" y="7311605"/>
-            <a:ext cx="12750799" cy="603941"/>
-          </a:xfrm>
-          <a:prstGeom prst="rect">
-            <a:avLst/>
-          </a:prstGeom>
-          <a:noFill/>
-        </p:spPr>
-        <p:txBody>
-          <a:bodyPr wrap="square" lIns="79925" tIns="39970" rIns="79925" bIns="39970" rtlCol="0">
-            <a:spAutoFit/>
-          </a:bodyPr>
-          <a:lstStyle/>
-          <a:p>
-            <a:r>
-              <a:rPr lang="en-US" sz="3400" b="0" baseline="0" dirty="0">
-                <a:latin typeface="Calibri" panose="020F0502020204030204" pitchFamily="34" charset="0"/>
-              </a:rPr>
-              <a:t>Insert objectives here</a:t>
-            </a:r>
-          </a:p>
-        </p:txBody>
-      </p:sp>
-      <p:sp>
-        <p:nvSpPr>
-          <p:cNvPr id="6" name="TextBox 5">
-            <a:extLst>
-              <a:ext uri="{FF2B5EF4-FFF2-40B4-BE49-F238E27FC236}">
-                <a16:creationId xmlns:a16="http://schemas.microsoft.com/office/drawing/2014/main" id="{A2C9A7E1-32CC-C6BA-949A-755B35E7E4B4}"/>
-              </a:ext>
-            </a:extLst>
-          </p:cNvPr>
-          <p:cNvSpPr txBox="1"/>
-          <p:nvPr/>
-        </p:nvSpPr>
-        <p:spPr>
-          <a:xfrm>
-            <a:off x="29589779" y="7311605"/>
-            <a:ext cx="12750799" cy="603941"/>
-          </a:xfrm>
-          <a:prstGeom prst="rect">
-            <a:avLst/>
-          </a:prstGeom>
-          <a:noFill/>
-        </p:spPr>
-        <p:txBody>
-          <a:bodyPr wrap="square" lIns="79925" tIns="39970" rIns="79925" bIns="39970" rtlCol="0">
-            <a:spAutoFit/>
-          </a:bodyPr>
-          <a:lstStyle/>
-          <a:p>
-            <a:r>
-              <a:rPr lang="en-US" sz="3400" b="0" baseline="0" dirty="0">
-                <a:latin typeface="Calibri" panose="020F0502020204030204" pitchFamily="34" charset="0"/>
-              </a:rPr>
-              <a:t>Insert results/discussion here</a:t>
-            </a:r>
-          </a:p>
-        </p:txBody>
-      </p:sp>
-      <p:sp>
-        <p:nvSpPr>
-          <p:cNvPr id="7" name="TextBox 6">
-            <a:extLst>
-              <a:ext uri="{FF2B5EF4-FFF2-40B4-BE49-F238E27FC236}">
-                <a16:creationId xmlns:a16="http://schemas.microsoft.com/office/drawing/2014/main" id="{162A11C8-251A-1F5A-3306-6B9DF4E54333}"/>
-              </a:ext>
-            </a:extLst>
-          </p:cNvPr>
-          <p:cNvSpPr txBox="1"/>
-          <p:nvPr/>
-        </p:nvSpPr>
-        <p:spPr>
-          <a:xfrm>
-            <a:off x="1527472" y="22210946"/>
-            <a:ext cx="12750799" cy="603941"/>
-          </a:xfrm>
-          <a:prstGeom prst="rect">
-            <a:avLst/>
-          </a:prstGeom>
-          <a:noFill/>
-        </p:spPr>
-        <p:txBody>
-          <a:bodyPr wrap="square" lIns="79925" tIns="39970" rIns="79925" bIns="39970" rtlCol="0">
-            <a:spAutoFit/>
-          </a:bodyPr>
-          <a:lstStyle/>
-          <a:p>
-            <a:r>
-              <a:rPr lang="en-US" sz="3400" b="0" baseline="0" dirty="0">
-                <a:latin typeface="Calibri" panose="020F0502020204030204" pitchFamily="34" charset="0"/>
-              </a:rPr>
-              <a:t>Insert background here</a:t>
-            </a:r>
-          </a:p>
-        </p:txBody>
-      </p:sp>
-      <p:sp>
-        <p:nvSpPr>
-          <p:cNvPr id="8" name="TextBox 7">
-            <a:extLst>
-              <a:ext uri="{FF2B5EF4-FFF2-40B4-BE49-F238E27FC236}">
-                <a16:creationId xmlns:a16="http://schemas.microsoft.com/office/drawing/2014/main" id="{F5BB0E9F-42DC-9FD4-6B5C-A77951C3CF72}"/>
-              </a:ext>
-            </a:extLst>
-          </p:cNvPr>
-          <p:cNvSpPr txBox="1"/>
-          <p:nvPr/>
-        </p:nvSpPr>
-        <p:spPr>
-          <a:xfrm>
-            <a:off x="15548272" y="14753058"/>
-            <a:ext cx="12750799" cy="603941"/>
-          </a:xfrm>
-          <a:prstGeom prst="rect">
-            <a:avLst/>
-          </a:prstGeom>
-          <a:noFill/>
-        </p:spPr>
-        <p:txBody>
-          <a:bodyPr wrap="square" lIns="79925" tIns="39970" rIns="79925" bIns="39970" rtlCol="0">
-            <a:spAutoFit/>
-          </a:bodyPr>
-          <a:lstStyle/>
-          <a:p>
-            <a:r>
-              <a:rPr lang="en-US" sz="3400" b="0" baseline="0" dirty="0">
-                <a:latin typeface="Calibri" panose="020F0502020204030204" pitchFamily="34" charset="0"/>
-              </a:rPr>
-              <a:t>Insert methods here</a:t>
-            </a:r>
-          </a:p>
-        </p:txBody>
-      </p:sp>
-      <p:sp>
-        <p:nvSpPr>
-          <p:cNvPr id="9" name="TextBox 8">
-            <a:extLst>
-              <a:ext uri="{FF2B5EF4-FFF2-40B4-BE49-F238E27FC236}">
-                <a16:creationId xmlns:a16="http://schemas.microsoft.com/office/drawing/2014/main" id="{7934801C-A016-F93C-87C8-0AB2A93708DB}"/>
-              </a:ext>
-            </a:extLst>
-          </p:cNvPr>
-          <p:cNvSpPr txBox="1"/>
-          <p:nvPr/>
-        </p:nvSpPr>
-        <p:spPr>
-          <a:xfrm>
-            <a:off x="29589779" y="26406428"/>
-            <a:ext cx="12750799" cy="603941"/>
-          </a:xfrm>
-          <a:prstGeom prst="rect">
-            <a:avLst/>
-          </a:prstGeom>
-          <a:noFill/>
-        </p:spPr>
-        <p:txBody>
-          <a:bodyPr wrap="square" lIns="79925" tIns="39970" rIns="79925" bIns="39970" rtlCol="0">
-            <a:spAutoFit/>
-          </a:bodyPr>
-          <a:lstStyle/>
-          <a:p>
-            <a:r>
-              <a:rPr lang="en-US" sz="3400" b="0" baseline="0" dirty="0">
-                <a:latin typeface="Calibri" panose="020F0502020204030204" pitchFamily="34" charset="0"/>
-              </a:rPr>
-              <a:t>Insert future direction here</a:t>
-            </a:r>
-          </a:p>
-        </p:txBody>
-      </p:sp>
-    </p:spTree>
-  </p:cSld>
-  <p:clrMapOvr>
-    <a:masterClrMapping/>
-  </p:clrMapOvr>
-</p:sld>
-</file>
-
-<file path=ppt/slides/slide3.xml><?xml version="1.0" encoding="utf-8"?>
 <p:sld xmlns:a="http://schemas.openxmlformats.org/drawingml/2006/main" xmlns:r="http://schemas.openxmlformats.org/officeDocument/2006/relationships" xmlns:p="http://schemas.openxmlformats.org/presentationml/2006/main">
   <p:cSld>
     <p:spTree>
@@ -9200,33 +7521,6 @@
 </file>
 
 <file path=customXml/item1.xml><?xml version="1.0" encoding="utf-8"?>
-<?mso-contentType ?>
-<FormTemplates xmlns="http://schemas.microsoft.com/sharepoint/v3/contenttype/forms">
-  <Display>DocumentLibraryForm</Display>
-  <Edit>DocumentLibraryForm</Edit>
-  <New>DocumentLibraryForm</New>
-</FormTemplates>
-</file>
-
-<file path=customXml/item2.xml><?xml version="1.0" encoding="utf-8"?>
-<p:properties xmlns:p="http://schemas.microsoft.com/office/2006/metadata/properties" xmlns:xsi="http://www.w3.org/2001/XMLSchema-instance" xmlns:pc="http://schemas.microsoft.com/office/infopath/2007/PartnerControls">
-  <documentManagement>
-    <lcf76f155ced4ddcb4097134ff3c332f xmlns="113e35d5-149a-42d0-9759-7e4251ca70ae">
-      <Terms xmlns="http://schemas.microsoft.com/office/infopath/2007/PartnerControls"/>
-    </lcf76f155ced4ddcb4097134ff3c332f>
-    <TaxCatchAll xmlns="7ea28f75-b447-4008-abb1-f022e6a61489" xsi:nil="true"/>
-    <SharedWithUsers xmlns="7ea28f75-b447-4008-abb1-f022e6a61489">
-      <UserInfo>
-        <DisplayName/>
-        <AccountId xsi:nil="true"/>
-        <AccountType/>
-      </UserInfo>
-    </SharedWithUsers>
-  </documentManagement>
-</p:properties>
-</file>
-
-<file path=customXml/item3.xml><?xml version="1.0" encoding="utf-8"?>
 <ct:contentTypeSchema xmlns:ct="http://schemas.microsoft.com/office/2006/metadata/contentType" xmlns:ma="http://schemas.microsoft.com/office/2006/metadata/properties/metaAttributes" ct:_="" ma:_="" ma:contentTypeName="Document" ma:contentTypeID="0x010100E102DA1231611544B7633ABC55414EFF" ma:contentTypeVersion="17" ma:contentTypeDescription="Create a new document." ma:contentTypeScope="" ma:versionID="5fa979140ce30341f4780377ce301feb">
   <xsd:schema xmlns:xsd="http://www.w3.org/2001/XMLSchema" xmlns:xs="http://www.w3.org/2001/XMLSchema" xmlns:p="http://schemas.microsoft.com/office/2006/metadata/properties" xmlns:ns2="113e35d5-149a-42d0-9759-7e4251ca70ae" xmlns:ns3="7ea28f75-b447-4008-abb1-f022e6a61489" targetNamespace="http://schemas.microsoft.com/office/2006/metadata/properties" ma:root="true" ma:fieldsID="47d8b4c5f05c57c39bcda140eb90ea8c" ns2:_="" ns3:_="">
     <xsd:import namespace="113e35d5-149a-42d0-9759-7e4251ca70ae"/>
@@ -9475,10 +7769,48 @@
 </ct:contentTypeSchema>
 </file>
 
+<file path=customXml/item2.xml><?xml version="1.0" encoding="utf-8"?>
+<p:properties xmlns:p="http://schemas.microsoft.com/office/2006/metadata/properties" xmlns:xsi="http://www.w3.org/2001/XMLSchema-instance" xmlns:pc="http://schemas.microsoft.com/office/infopath/2007/PartnerControls">
+  <documentManagement>
+    <lcf76f155ced4ddcb4097134ff3c332f xmlns="113e35d5-149a-42d0-9759-7e4251ca70ae">
+      <Terms xmlns="http://schemas.microsoft.com/office/infopath/2007/PartnerControls"/>
+    </lcf76f155ced4ddcb4097134ff3c332f>
+    <TaxCatchAll xmlns="7ea28f75-b447-4008-abb1-f022e6a61489" xsi:nil="true"/>
+    <SharedWithUsers xmlns="7ea28f75-b447-4008-abb1-f022e6a61489">
+      <UserInfo>
+        <DisplayName/>
+        <AccountId xsi:nil="true"/>
+        <AccountType/>
+      </UserInfo>
+    </SharedWithUsers>
+  </documentManagement>
+</p:properties>
+</file>
+
+<file path=customXml/item3.xml><?xml version="1.0" encoding="utf-8"?>
+<?mso-contentType ?>
+<FormTemplates xmlns="http://schemas.microsoft.com/sharepoint/v3/contenttype/forms">
+  <Display>DocumentLibraryForm</Display>
+  <Edit>DocumentLibraryForm</Edit>
+  <New>DocumentLibraryForm</New>
+</FormTemplates>
+</file>
+
 <file path=customXml/itemProps1.xml><?xml version="1.0" encoding="utf-8"?>
-<ds:datastoreItem xmlns:ds="http://schemas.openxmlformats.org/officeDocument/2006/customXml" ds:itemID="{4CC2D6B8-4129-4487-B8A1-A1EC5673B739}">
+<ds:datastoreItem xmlns:ds="http://schemas.openxmlformats.org/officeDocument/2006/customXml" ds:itemID="{7C0D33F5-A399-4B4D-A3F4-58739A033274}">
   <ds:schemaRefs>
-    <ds:schemaRef ds:uri="http://schemas.microsoft.com/sharepoint/v3/contenttype/forms"/>
+    <ds:schemaRef ds:uri="http://schemas.microsoft.com/office/2006/metadata/contentType"/>
+    <ds:schemaRef ds:uri="http://schemas.microsoft.com/office/2006/metadata/properties/metaAttributes"/>
+    <ds:schemaRef ds:uri="http://www.w3.org/2001/XMLSchema"/>
+    <ds:schemaRef ds:uri="http://schemas.microsoft.com/office/2006/metadata/properties"/>
+    <ds:schemaRef ds:uri="113e35d5-149a-42d0-9759-7e4251ca70ae"/>
+    <ds:schemaRef ds:uri="7ea28f75-b447-4008-abb1-f022e6a61489"/>
+    <ds:schemaRef ds:uri="http://schemas.microsoft.com/office/2006/documentManagement/types"/>
+    <ds:schemaRef ds:uri="http://schemas.microsoft.com/office/infopath/2007/PartnerControls"/>
+    <ds:schemaRef ds:uri="http://schemas.openxmlformats.org/package/2006/metadata/core-properties"/>
+    <ds:schemaRef ds:uri="http://purl.org/dc/elements/1.1/"/>
+    <ds:schemaRef ds:uri="http://purl.org/dc/terms/"/>
+    <ds:schemaRef ds:uri="http://schemas.microsoft.com/internal/obd"/>
   </ds:schemaRefs>
 </ds:datastoreItem>
 </file>
@@ -9495,20 +7827,9 @@
 </file>
 
 <file path=customXml/itemProps3.xml><?xml version="1.0" encoding="utf-8"?>
-<ds:datastoreItem xmlns:ds="http://schemas.openxmlformats.org/officeDocument/2006/customXml" ds:itemID="{7C0D33F5-A399-4B4D-A3F4-58739A033274}">
+<ds:datastoreItem xmlns:ds="http://schemas.openxmlformats.org/officeDocument/2006/customXml" ds:itemID="{4CC2D6B8-4129-4487-B8A1-A1EC5673B739}">
   <ds:schemaRefs>
-    <ds:schemaRef ds:uri="http://schemas.microsoft.com/office/2006/metadata/contentType"/>
-    <ds:schemaRef ds:uri="http://schemas.microsoft.com/office/2006/metadata/properties/metaAttributes"/>
-    <ds:schemaRef ds:uri="http://www.w3.org/2001/XMLSchema"/>
-    <ds:schemaRef ds:uri="http://schemas.microsoft.com/office/2006/metadata/properties"/>
-    <ds:schemaRef ds:uri="113e35d5-149a-42d0-9759-7e4251ca70ae"/>
-    <ds:schemaRef ds:uri="7ea28f75-b447-4008-abb1-f022e6a61489"/>
-    <ds:schemaRef ds:uri="http://schemas.microsoft.com/office/2006/documentManagement/types"/>
-    <ds:schemaRef ds:uri="http://schemas.microsoft.com/office/infopath/2007/PartnerControls"/>
-    <ds:schemaRef ds:uri="http://schemas.openxmlformats.org/package/2006/metadata/core-properties"/>
-    <ds:schemaRef ds:uri="http://purl.org/dc/elements/1.1/"/>
-    <ds:schemaRef ds:uri="http://purl.org/dc/terms/"/>
-    <ds:schemaRef ds:uri="http://schemas.microsoft.com/internal/obd"/>
+    <ds:schemaRef ds:uri="http://schemas.microsoft.com/sharepoint/v3/contenttype/forms"/>
   </ds:schemaRefs>
 </ds:datastoreItem>
 </file>
</xml_diff>

<commit_message>
Refine Phase 4 policy and recovery rebound analysis visuals
Updated recovery rebound explainer charts, clarified scenario labels, added endpoint uncertainty ranges, improved feature-change summary tables, and saved Excel-safe CSV outputs for final report and presentation use.
</commit_message>
<xml_diff>
--- a/project_reports/Poster_RiveraruizJose-1-36x48-1.pptx
+++ b/project_reports/Poster_RiveraruizJose-1-36x48-1.pptx
@@ -210,7 +210,7 @@
             <a:fld id="{CFB1F554-8471-F74E-95A3-3E7FC8AE6388}" type="datetimeFigureOut">
               <a:rPr lang="en-US" smtClean="0"/>
               <a:pPr/>
-              <a:t>4/29/26</a:t>
+              <a:t>5/2/26</a:t>
             </a:fld>
             <a:endParaRPr lang="en-US"/>
           </a:p>
@@ -771,7 +771,7 @@
             <a:fld id="{0C2C9624-8537-344B-A181-774C3CF89A66}" type="datetimeFigureOut">
               <a:rPr lang="en-US" smtClean="0"/>
               <a:pPr/>
-              <a:t>4/29/26</a:t>
+              <a:t>5/2/26</a:t>
             </a:fld>
             <a:endParaRPr lang="en-US"/>
           </a:p>
@@ -936,7 +936,7 @@
             <a:fld id="{0C2C9624-8537-344B-A181-774C3CF89A66}" type="datetimeFigureOut">
               <a:rPr lang="en-US" smtClean="0"/>
               <a:pPr/>
-              <a:t>4/29/26</a:t>
+              <a:t>5/2/26</a:t>
             </a:fld>
             <a:endParaRPr lang="en-US"/>
           </a:p>
@@ -1111,7 +1111,7 @@
             <a:fld id="{0C2C9624-8537-344B-A181-774C3CF89A66}" type="datetimeFigureOut">
               <a:rPr lang="en-US" smtClean="0"/>
               <a:pPr/>
-              <a:t>4/29/26</a:t>
+              <a:t>5/2/26</a:t>
             </a:fld>
             <a:endParaRPr lang="en-US"/>
           </a:p>
@@ -1276,7 +1276,7 @@
             <a:fld id="{0C2C9624-8537-344B-A181-774C3CF89A66}" type="datetimeFigureOut">
               <a:rPr lang="en-US" smtClean="0"/>
               <a:pPr/>
-              <a:t>4/29/26</a:t>
+              <a:t>5/2/26</a:t>
             </a:fld>
             <a:endParaRPr lang="en-US"/>
           </a:p>
@@ -1518,7 +1518,7 @@
             <a:fld id="{0C2C9624-8537-344B-A181-774C3CF89A66}" type="datetimeFigureOut">
               <a:rPr lang="en-US" smtClean="0"/>
               <a:pPr/>
-              <a:t>4/29/26</a:t>
+              <a:t>5/2/26</a:t>
             </a:fld>
             <a:endParaRPr lang="en-US"/>
           </a:p>
@@ -1800,7 +1800,7 @@
             <a:fld id="{0C2C9624-8537-344B-A181-774C3CF89A66}" type="datetimeFigureOut">
               <a:rPr lang="en-US" smtClean="0"/>
               <a:pPr/>
-              <a:t>4/29/26</a:t>
+              <a:t>5/2/26</a:t>
             </a:fld>
             <a:endParaRPr lang="en-US"/>
           </a:p>
@@ -2221,7 +2221,7 @@
             <a:fld id="{0C2C9624-8537-344B-A181-774C3CF89A66}" type="datetimeFigureOut">
               <a:rPr lang="en-US" smtClean="0"/>
               <a:pPr/>
-              <a:t>4/29/26</a:t>
+              <a:t>5/2/26</a:t>
             </a:fld>
             <a:endParaRPr lang="en-US"/>
           </a:p>
@@ -2335,7 +2335,7 @@
             <a:fld id="{0C2C9624-8537-344B-A181-774C3CF89A66}" type="datetimeFigureOut">
               <a:rPr lang="en-US" smtClean="0"/>
               <a:pPr/>
-              <a:t>4/29/26</a:t>
+              <a:t>5/2/26</a:t>
             </a:fld>
             <a:endParaRPr lang="en-US"/>
           </a:p>
@@ -2427,7 +2427,7 @@
             <a:fld id="{0C2C9624-8537-344B-A181-774C3CF89A66}" type="datetimeFigureOut">
               <a:rPr lang="en-US" smtClean="0"/>
               <a:pPr/>
-              <a:t>4/29/26</a:t>
+              <a:t>5/2/26</a:t>
             </a:fld>
             <a:endParaRPr lang="en-US"/>
           </a:p>
@@ -2699,7 +2699,7 @@
             <a:fld id="{0C2C9624-8537-344B-A181-774C3CF89A66}" type="datetimeFigureOut">
               <a:rPr lang="en-US" smtClean="0"/>
               <a:pPr/>
-              <a:t>4/29/26</a:t>
+              <a:t>5/2/26</a:t>
             </a:fld>
             <a:endParaRPr lang="en-US"/>
           </a:p>
@@ -2948,7 +2948,7 @@
             <a:fld id="{0C2C9624-8537-344B-A181-774C3CF89A66}" type="datetimeFigureOut">
               <a:rPr lang="en-US" smtClean="0"/>
               <a:pPr/>
-              <a:t>4/29/26</a:t>
+              <a:t>5/2/26</a:t>
             </a:fld>
             <a:endParaRPr lang="en-US"/>
           </a:p>
@@ -3156,7 +3156,7 @@
             <a:fld id="{0C2C9624-8537-344B-A181-774C3CF89A66}" type="datetimeFigureOut">
               <a:rPr lang="en-US" smtClean="0"/>
               <a:pPr/>
-              <a:t>4/29/26</a:t>
+              <a:t>5/2/26</a:t>
             </a:fld>
             <a:endParaRPr lang="en-US"/>
           </a:p>
@@ -4717,7 +4717,7 @@
                   <a:schemeClr val="bg1"/>
                 </a:solidFill>
               </a:rPr>
-              <a:t>Future Direction</a:t>
+              <a:t>References</a:t>
             </a:r>
           </a:p>
         </p:txBody>
@@ -5219,7 +5219,7 @@
         <p:spPr>
           <a:xfrm>
             <a:off x="29430755" y="7164120"/>
-            <a:ext cx="13090715" cy="18855091"/>
+            <a:ext cx="13090715" cy="17747095"/>
           </a:xfrm>
           <a:prstGeom prst="rect">
             <a:avLst/>
@@ -5474,17 +5474,6 @@
           </a:p>
           <a:p>
             <a:endParaRPr lang="en-US" sz="3600" dirty="0">
-              <a:latin typeface="Calibri" panose="020F0502020204030204" pitchFamily="34" charset="0"/>
-            </a:endParaRPr>
-          </a:p>
-          <a:p>
-            <a:r>
-              <a:rPr lang="en-US" sz="3600" dirty="0">
-                <a:latin typeface="Calibri" panose="020F0502020204030204" pitchFamily="34" charset="0"/>
-              </a:rPr>
-              <a:t>Policy scenarios slow decline, but only strong recovery + return migration produces stabilization</a:t>
-            </a:r>
-            <a:endParaRPr lang="en-US" sz="3600" b="0" baseline="0" dirty="0">
               <a:latin typeface="Calibri" panose="020F0502020204030204" pitchFamily="34" charset="0"/>
             </a:endParaRPr>
           </a:p>
@@ -5505,7 +5494,7 @@
         <p:spPr>
           <a:xfrm>
             <a:off x="1527472" y="22004467"/>
-            <a:ext cx="12750799" cy="7251915"/>
+            <a:ext cx="12750799" cy="7805912"/>
           </a:xfrm>
           <a:prstGeom prst="rect">
             <a:avLst/>
@@ -5538,7 +5527,7 @@
               <a:rPr lang="en-US" sz="3600" b="0" baseline="0" dirty="0">
                 <a:latin typeface="Calibri" panose="020F0502020204030204" pitchFamily="34" charset="0"/>
               </a:rPr>
-              <a:t>Decline is uneven across regions (South and East more affected) </a:t>
+              <a:t>Decline is uneven across regions (South and East more affected as seen on maps below) </a:t>
             </a:r>
           </a:p>
           <a:p>
@@ -6124,8 +6113,8 @@
         </p:nvSpPr>
         <p:spPr>
           <a:xfrm>
-            <a:off x="29449103" y="28340732"/>
-            <a:ext cx="13090715" cy="3373930"/>
+            <a:off x="29449103" y="28008221"/>
+            <a:ext cx="13090715" cy="3296986"/>
           </a:xfrm>
           <a:prstGeom prst="rect">
             <a:avLst/>
@@ -6149,10 +6138,87 @@
               <a:buChar char="•"/>
             </a:pPr>
             <a:r>
-              <a:rPr lang="en-US" altLang="en-US" sz="3600" dirty="0">
-                <a:latin typeface="Arial" panose="020B0604020202020204" pitchFamily="34" charset="0"/>
-              </a:rPr>
-              <a:t>Identify policy combinations that can meaningfully alter long-term population trajectories</a:t>
+              <a:rPr lang="en-US" sz="3500" dirty="0">
+                <a:solidFill>
+                  <a:srgbClr val="000000"/>
+                </a:solidFill>
+                <a:latin typeface="Arial" charset="0"/>
+                <a:ea typeface="Arial" charset="0"/>
+                <a:cs typeface="Arial" charset="0"/>
+              </a:rPr>
+              <a:t>U.S. Census Bureau. American Community Survey (ACS)</a:t>
+            </a:r>
+          </a:p>
+          <a:p>
+            <a:pPr marL="571500" indent="-571500" defTabSz="914400" eaLnBrk="0" fontAlgn="base" hangingPunct="0">
+              <a:spcBef>
+                <a:spcPct val="0"/>
+              </a:spcBef>
+              <a:spcAft>
+                <a:spcPct val="0"/>
+              </a:spcAft>
+              <a:buFont typeface="Arial" panose="020B0604020202020204" pitchFamily="34" charset="0"/>
+              <a:buChar char="•"/>
+            </a:pPr>
+            <a:r>
+              <a:rPr lang="en-US" sz="3500" dirty="0">
+                <a:solidFill>
+                  <a:srgbClr val="000000"/>
+                </a:solidFill>
+                <a:latin typeface="Arial" charset="0"/>
+                <a:ea typeface="Arial" charset="0"/>
+                <a:cs typeface="Arial" charset="0"/>
+              </a:rPr>
+              <a:t>U.S. Census Bureau. Population Estimates Program (PEP): Puerto Rico Municipal Population Estimates, Vintage 2024.</a:t>
+            </a:r>
+            <a:endParaRPr lang="en-US" sz="3500" b="0" baseline="0" dirty="0">
+              <a:latin typeface="Calibri" panose="020F0502020204030204" pitchFamily="34" charset="0"/>
+            </a:endParaRPr>
+          </a:p>
+          <a:p>
+            <a:pPr marL="571500" indent="-571500" defTabSz="914400" eaLnBrk="0" fontAlgn="base" hangingPunct="0">
+              <a:spcBef>
+                <a:spcPct val="0"/>
+              </a:spcBef>
+              <a:spcAft>
+                <a:spcPct val="0"/>
+              </a:spcAft>
+              <a:buFont typeface="Arial" panose="020B0604020202020204" pitchFamily="34" charset="0"/>
+              <a:buChar char="•"/>
+            </a:pPr>
+            <a:r>
+              <a:rPr lang="en-US" sz="3500" dirty="0">
+                <a:solidFill>
+                  <a:srgbClr val="000000"/>
+                </a:solidFill>
+                <a:latin typeface="Arial" charset="0"/>
+                <a:ea typeface="Arial" charset="0"/>
+                <a:cs typeface="Arial" charset="0"/>
+              </a:rPr>
+              <a:t>NOAA National Hurricane Center</a:t>
+            </a:r>
+          </a:p>
+          <a:p>
+            <a:pPr marL="571500" indent="-571500" defTabSz="914400" eaLnBrk="0" fontAlgn="base" hangingPunct="0">
+              <a:spcBef>
+                <a:spcPct val="0"/>
+              </a:spcBef>
+              <a:spcAft>
+                <a:spcPct val="0"/>
+              </a:spcAft>
+              <a:buFont typeface="Arial" panose="020B0604020202020204" pitchFamily="34" charset="0"/>
+              <a:buChar char="•"/>
+            </a:pPr>
+            <a:r>
+              <a:rPr lang="en-US" sz="3500" dirty="0">
+                <a:solidFill>
+                  <a:srgbClr val="000000"/>
+                </a:solidFill>
+                <a:latin typeface="Arial" charset="0"/>
+                <a:ea typeface="Arial" charset="0"/>
+                <a:cs typeface="Arial" charset="0"/>
+              </a:rPr>
+              <a:t>USGS (United States Geological Survey)</a:t>
             </a:r>
           </a:p>
           <a:p>
@@ -6166,33 +6232,7 @@
               <a:buFont typeface="Arial" panose="020B0604020202020204" pitchFamily="34" charset="0"/>
               <a:buChar char="•"/>
             </a:pPr>
-            <a:r>
-              <a:rPr lang="en-US" altLang="en-US" sz="3600" dirty="0">
-                <a:latin typeface="Arial" panose="020B0604020202020204" pitchFamily="34" charset="0"/>
-              </a:rPr>
-              <a:t>Incorporate uncertainty and scenario ranges to better communicate risk in population predictions</a:t>
-            </a:r>
-          </a:p>
-          <a:p>
-            <a:pPr marL="571500" lvl="0" indent="-571500" defTabSz="914400" eaLnBrk="0" fontAlgn="base" hangingPunct="0">
-              <a:spcBef>
-                <a:spcPct val="0"/>
-              </a:spcBef>
-              <a:spcAft>
-                <a:spcPct val="0"/>
-              </a:spcAft>
-              <a:buFont typeface="Arial" panose="020B0604020202020204" pitchFamily="34" charset="0"/>
-              <a:buChar char="•"/>
-            </a:pPr>
-            <a:r>
-              <a:rPr lang="en-US" altLang="en-US" sz="3600" dirty="0">
-                <a:latin typeface="Arial" panose="020B0604020202020204" pitchFamily="34" charset="0"/>
-              </a:rPr>
-              <a:t>Explore spatial models to better capture regional interactions</a:t>
-            </a:r>
-          </a:p>
-          <a:p>
-            <a:endParaRPr lang="en-US" sz="3400" b="0" baseline="0" dirty="0">
+            <a:endParaRPr lang="en-US" sz="3400" dirty="0">
               <a:latin typeface="Calibri" panose="020F0502020204030204" pitchFamily="34" charset="0"/>
             </a:endParaRPr>
           </a:p>
@@ -6240,75 +6280,6 @@
       </p:pic>
       <p:pic>
         <p:nvPicPr>
-          <p:cNvPr id="12" name="Picture 11" descr="A graph with lines and numbers&#10;&#10;AI-generated content may be incorrect.">
-            <a:extLst>
-              <a:ext uri="{FF2B5EF4-FFF2-40B4-BE49-F238E27FC236}">
-                <a16:creationId xmlns:a16="http://schemas.microsoft.com/office/drawing/2014/main" id="{B558D406-1AB8-4520-900D-F414515F7FB6}"/>
-              </a:ext>
-            </a:extLst>
-          </p:cNvPr>
-          <p:cNvPicPr>
-            <a:picLocks noChangeAspect="1"/>
-          </p:cNvPicPr>
-          <p:nvPr/>
-        </p:nvPicPr>
-        <p:blipFill>
-          <a:blip r:embed="rId5">
-            <a:alphaModFix amt="85000"/>
-            <a:extLst>
-              <a:ext uri="{28A0092B-C50C-407E-A947-70E740481C1C}">
-                <a14:useLocalDpi xmlns:a14="http://schemas.microsoft.com/office/drawing/2010/main" val="0"/>
-              </a:ext>
-            </a:extLst>
-          </a:blip>
-          <a:stretch>
-            <a:fillRect/>
-          </a:stretch>
-        </p:blipFill>
-        <p:spPr>
-          <a:xfrm>
-            <a:off x="36267000" y="21029145"/>
-            <a:ext cx="6096728" cy="3271960"/>
-          </a:xfrm>
-          <a:prstGeom prst="rect">
-            <a:avLst/>
-          </a:prstGeom>
-        </p:spPr>
-      </p:pic>
-      <p:pic>
-        <p:nvPicPr>
-          <p:cNvPr id="14" name="Picture 13" descr="A graph of a line graph&#10;&#10;AI-generated content may be incorrect.">
-            <a:extLst>
-              <a:ext uri="{FF2B5EF4-FFF2-40B4-BE49-F238E27FC236}">
-                <a16:creationId xmlns:a16="http://schemas.microsoft.com/office/drawing/2014/main" id="{D3AF9EEC-EE28-26A8-8EA1-95527F6CCE40}"/>
-              </a:ext>
-            </a:extLst>
-          </p:cNvPr>
-          <p:cNvPicPr>
-            <a:picLocks noChangeAspect="1"/>
-          </p:cNvPicPr>
-          <p:nvPr/>
-        </p:nvPicPr>
-        <p:blipFill>
-          <a:blip r:embed="rId6">
-            <a:alphaModFix amt="85000"/>
-          </a:blip>
-          <a:stretch>
-            <a:fillRect/>
-          </a:stretch>
-        </p:blipFill>
-        <p:spPr>
-          <a:xfrm>
-            <a:off x="29449103" y="21005943"/>
-            <a:ext cx="6096728" cy="3295162"/>
-          </a:xfrm>
-          <a:prstGeom prst="rect">
-            <a:avLst/>
-          </a:prstGeom>
-        </p:spPr>
-      </p:pic>
-      <p:pic>
-        <p:nvPicPr>
           <p:cNvPr id="30" name="Picture 29" descr="A diagram of a model&#10;&#10;AI-generated content may be incorrect.">
             <a:extLst>
               <a:ext uri="{FF2B5EF4-FFF2-40B4-BE49-F238E27FC236}">
@@ -6322,7 +6293,7 @@
           <p:nvPr/>
         </p:nvPicPr>
         <p:blipFill>
-          <a:blip r:embed="rId7">
+          <a:blip r:embed="rId5">
             <a:alphaModFix amt="85000"/>
           </a:blip>
           <a:stretch>
@@ -6354,14 +6325,14 @@
           <p:nvPr/>
         </p:nvPicPr>
         <p:blipFill>
-          <a:blip r:embed="rId8"/>
+          <a:blip r:embed="rId6"/>
           <a:stretch>
             <a:fillRect/>
           </a:stretch>
         </p:blipFill>
         <p:spPr>
           <a:xfrm>
-            <a:off x="8329698" y="29256382"/>
+            <a:off x="8329698" y="29467396"/>
             <a:ext cx="6040247" cy="2310284"/>
           </a:xfrm>
           <a:prstGeom prst="rect">
@@ -6387,14 +6358,14 @@
           <p:nvPr/>
         </p:nvPicPr>
         <p:blipFill>
-          <a:blip r:embed="rId9"/>
+          <a:blip r:embed="rId7"/>
           <a:stretch>
             <a:fillRect/>
           </a:stretch>
         </p:blipFill>
         <p:spPr>
           <a:xfrm>
-            <a:off x="1435798" y="29256382"/>
+            <a:off x="1435798" y="29467396"/>
             <a:ext cx="6031429" cy="2310284"/>
           </a:xfrm>
           <a:prstGeom prst="rect">
@@ -6403,6 +6374,99 @@
           <a:ln>
             <a:noFill/>
           </a:ln>
+        </p:spPr>
+      </p:pic>
+      <p:pic>
+        <p:nvPicPr>
+          <p:cNvPr id="10" name="Picture 9">
+            <a:extLst>
+              <a:ext uri="{FF2B5EF4-FFF2-40B4-BE49-F238E27FC236}">
+                <a16:creationId xmlns:a16="http://schemas.microsoft.com/office/drawing/2014/main" id="{A11B4F02-FA86-6159-06F1-65AC3A46E7F4}"/>
+              </a:ext>
+            </a:extLst>
+          </p:cNvPr>
+          <p:cNvPicPr>
+            <a:picLocks noChangeAspect="1"/>
+          </p:cNvPicPr>
+          <p:nvPr/>
+        </p:nvPicPr>
+        <p:blipFill>
+          <a:blip r:embed="rId8"/>
+          <a:srcRect l="11310" t="13705" r="3402" b="43365"/>
+          <a:stretch>
+            <a:fillRect/>
+          </a:stretch>
+        </p:blipFill>
+        <p:spPr>
+          <a:xfrm>
+            <a:off x="29314501" y="20425541"/>
+            <a:ext cx="8863327" cy="3306309"/>
+          </a:xfrm>
+          <a:prstGeom prst="rect">
+            <a:avLst/>
+          </a:prstGeom>
+        </p:spPr>
+      </p:pic>
+      <p:pic>
+        <p:nvPicPr>
+          <p:cNvPr id="34" name="Picture 33">
+            <a:extLst>
+              <a:ext uri="{FF2B5EF4-FFF2-40B4-BE49-F238E27FC236}">
+                <a16:creationId xmlns:a16="http://schemas.microsoft.com/office/drawing/2014/main" id="{19965D59-7D92-0E21-565C-918D4835B0EB}"/>
+              </a:ext>
+            </a:extLst>
+          </p:cNvPr>
+          <p:cNvPicPr>
+            <a:picLocks noChangeAspect="1"/>
+          </p:cNvPicPr>
+          <p:nvPr/>
+        </p:nvPicPr>
+        <p:blipFill>
+          <a:blip r:embed="rId9"/>
+          <a:srcRect t="24073" b="15494"/>
+          <a:stretch>
+            <a:fillRect/>
+          </a:stretch>
+        </p:blipFill>
+        <p:spPr>
+          <a:xfrm>
+            <a:off x="29627009" y="23792354"/>
+            <a:ext cx="12526943" cy="2303500"/>
+          </a:xfrm>
+          <a:prstGeom prst="rect">
+            <a:avLst/>
+          </a:prstGeom>
+        </p:spPr>
+      </p:pic>
+      <p:pic>
+        <p:nvPicPr>
+          <p:cNvPr id="35" name="Picture 34">
+            <a:extLst>
+              <a:ext uri="{FF2B5EF4-FFF2-40B4-BE49-F238E27FC236}">
+                <a16:creationId xmlns:a16="http://schemas.microsoft.com/office/drawing/2014/main" id="{4077896C-CD47-ACB4-3E56-C9DDE44CAD04}"/>
+              </a:ext>
+            </a:extLst>
+          </p:cNvPr>
+          <p:cNvPicPr>
+            <a:picLocks noChangeAspect="1"/>
+          </p:cNvPicPr>
+          <p:nvPr/>
+        </p:nvPicPr>
+        <p:blipFill>
+          <a:blip r:embed="rId10"/>
+          <a:srcRect l="1824" t="65520" r="45947"/>
+          <a:stretch>
+            <a:fillRect/>
+          </a:stretch>
+        </p:blipFill>
+        <p:spPr>
+          <a:xfrm>
+            <a:off x="38263659" y="20443696"/>
+            <a:ext cx="4423049" cy="2164019"/>
+          </a:xfrm>
+          <a:prstGeom prst="rect">
+            <a:avLst/>
+          </a:prstGeom>
         </p:spPr>
       </p:pic>
     </p:spTree>
@@ -7770,6 +7834,15 @@
 </file>
 
 <file path=customXml/item2.xml><?xml version="1.0" encoding="utf-8"?>
+<?mso-contentType ?>
+<FormTemplates xmlns="http://schemas.microsoft.com/sharepoint/v3/contenttype/forms">
+  <Display>DocumentLibraryForm</Display>
+  <Edit>DocumentLibraryForm</Edit>
+  <New>DocumentLibraryForm</New>
+</FormTemplates>
+</file>
+
+<file path=customXml/item3.xml><?xml version="1.0" encoding="utf-8"?>
 <p:properties xmlns:p="http://schemas.microsoft.com/office/2006/metadata/properties" xmlns:xsi="http://www.w3.org/2001/XMLSchema-instance" xmlns:pc="http://schemas.microsoft.com/office/infopath/2007/PartnerControls">
   <documentManagement>
     <lcf76f155ced4ddcb4097134ff3c332f xmlns="113e35d5-149a-42d0-9759-7e4251ca70ae">
@@ -7785,15 +7858,6 @@
     </SharedWithUsers>
   </documentManagement>
 </p:properties>
-</file>
-
-<file path=customXml/item3.xml><?xml version="1.0" encoding="utf-8"?>
-<?mso-contentType ?>
-<FormTemplates xmlns="http://schemas.microsoft.com/sharepoint/v3/contenttype/forms">
-  <Display>DocumentLibraryForm</Display>
-  <Edit>DocumentLibraryForm</Edit>
-  <New>DocumentLibraryForm</New>
-</FormTemplates>
 </file>
 
 <file path=customXml/itemProps1.xml><?xml version="1.0" encoding="utf-8"?>
@@ -7816,6 +7880,14 @@
 </file>
 
 <file path=customXml/itemProps2.xml><?xml version="1.0" encoding="utf-8"?>
+<ds:datastoreItem xmlns:ds="http://schemas.openxmlformats.org/officeDocument/2006/customXml" ds:itemID="{4CC2D6B8-4129-4487-B8A1-A1EC5673B739}">
+  <ds:schemaRefs>
+    <ds:schemaRef ds:uri="http://schemas.microsoft.com/sharepoint/v3/contenttype/forms"/>
+  </ds:schemaRefs>
+</ds:datastoreItem>
+</file>
+
+<file path=customXml/itemProps3.xml><?xml version="1.0" encoding="utf-8"?>
 <ds:datastoreItem xmlns:ds="http://schemas.openxmlformats.org/officeDocument/2006/customXml" ds:itemID="{A0BD6F2F-D097-4693-BA4C-210A2E261A36}">
   <ds:schemaRefs>
     <ds:schemaRef ds:uri="http://schemas.microsoft.com/office/2006/metadata/properties"/>
@@ -7824,12 +7896,4 @@
     <ds:schemaRef ds:uri="7ea28f75-b447-4008-abb1-f022e6a61489"/>
   </ds:schemaRefs>
 </ds:datastoreItem>
-</file>
-
-<file path=customXml/itemProps3.xml><?xml version="1.0" encoding="utf-8"?>
-<ds:datastoreItem xmlns:ds="http://schemas.openxmlformats.org/officeDocument/2006/customXml" ds:itemID="{4CC2D6B8-4129-4487-B8A1-A1EC5673B739}">
-  <ds:schemaRefs>
-    <ds:schemaRef ds:uri="http://schemas.microsoft.com/sharepoint/v3/contenttype/forms"/>
-  </ds:schemaRefs>
-</ds:datastoreItem>
 </file>
</xml_diff>